<commit_message>
making some changes from sana
</commit_message>
<xml_diff>
--- a/poster/QB_Archetypes_Poster_36x24.pptx
+++ b/poster/QB_Archetypes_Poster_36x24.pptx
@@ -1123,94 +1123,6 @@
       </p:sp>
       <p:sp>
         <p:nvSpPr>
-          <p:cNvPr id="6" name="Shape 4"/>
-          <p:cNvSpPr/>
-          <p:nvPr/>
-        </p:nvSpPr>
-        <p:spPr>
-          <a:xfrm>
-            <a:off x="27889200" y="182880"/>
-            <a:ext cx="4572000" cy="2011680"/>
-          </a:xfrm>
-          <a:prstGeom prst="rect">
-            <a:avLst/>
-          </a:prstGeom>
-          <a:solidFill>
-            <a:srgbClr val="002868"/>
-          </a:solidFill>
-          <a:ln w="50800">
-            <a:solidFill>
-              <a:srgbClr val="F4A620"/>
-            </a:solidFill>
-            <a:prstDash val="solid"/>
-          </a:ln>
-        </p:spPr>
-        <p:txBody>
-          <a:bodyPr/>
-          <a:lstStyle/>
-          <a:p>
-            <a:endParaRPr lang="en-US"/>
-          </a:p>
-        </p:txBody>
-      </p:sp>
-      <p:sp>
-        <p:nvSpPr>
-          <p:cNvPr id="7" name="Text 5"/>
-          <p:cNvSpPr/>
-          <p:nvPr/>
-        </p:nvSpPr>
-        <p:spPr>
-          <a:xfrm>
-            <a:off x="27889200" y="182880"/>
-            <a:ext cx="4572000" cy="2011680"/>
-          </a:xfrm>
-          <a:prstGeom prst="rect">
-            <a:avLst/>
-          </a:prstGeom>
-          <a:noFill/>
-          <a:ln/>
-        </p:spPr>
-        <p:txBody>
-          <a:bodyPr wrap="square" rtlCol="0" anchor="ctr"/>
-          <a:lstStyle/>
-          <a:p>
-            <a:pPr marL="0" indent="0" algn="ctr">
-              <a:buNone/>
-            </a:pPr>
-            <a:r>
-              <a:rPr lang="en-US" sz="2600" b="1" dirty="0">
-                <a:solidFill>
-                  <a:srgbClr val="F4A620"/>
-                </a:solidFill>
-                <a:latin typeface="Trebuchet MS" pitchFamily="34" charset="0"/>
-                <a:ea typeface="Trebuchet MS" pitchFamily="34" charset="-122"/>
-                <a:cs typeface="Trebuchet MS" pitchFamily="34" charset="-120"/>
-              </a:rPr>
-              <a:t>UCONN</a:t>
-            </a:r>
-            <a:endParaRPr lang="en-US" sz="2600" dirty="0"/>
-          </a:p>
-          <a:p>
-            <a:pPr marL="0" indent="0" algn="ctr">
-              <a:buNone/>
-            </a:pPr>
-            <a:r>
-              <a:rPr lang="en-US" sz="2600" b="1" dirty="0">
-                <a:solidFill>
-                  <a:srgbClr val="F4A620"/>
-                </a:solidFill>
-                <a:latin typeface="Trebuchet MS" pitchFamily="34" charset="0"/>
-                <a:ea typeface="Trebuchet MS" pitchFamily="34" charset="-122"/>
-                <a:cs typeface="Trebuchet MS" pitchFamily="34" charset="-120"/>
-              </a:rPr>
-              <a:t>DATA SCIENCE</a:t>
-            </a:r>
-            <a:endParaRPr lang="en-US" sz="2600" dirty="0"/>
-          </a:p>
-        </p:txBody>
-      </p:sp>
-      <p:sp>
-        <p:nvSpPr>
           <p:cNvPr id="8" name="Shape 6"/>
           <p:cNvSpPr/>
           <p:nvPr/>
@@ -1256,7 +1168,7 @@
         </p:nvSpPr>
         <p:spPr>
           <a:xfrm>
-            <a:off x="9052560" y="2743200"/>
+            <a:off x="8833104" y="2816352"/>
             <a:ext cx="10972800" cy="18928080"/>
           </a:xfrm>
           <a:prstGeom prst="rect">
@@ -1420,10 +1332,8 @@
                   <a:srgbClr val="FFFFFF"/>
                 </a:solidFill>
                 <a:latin typeface="Trebuchet MS" pitchFamily="34" charset="0"/>
-                <a:ea typeface="Trebuchet MS" pitchFamily="34" charset="-122"/>
-                <a:cs typeface="Trebuchet MS" pitchFamily="34" charset="-120"/>
               </a:rPr>
-              <a:t>INTRODUCTION</a:t>
+              <a:t>ABSTRACT</a:t>
             </a:r>
             <a:endParaRPr lang="en-US" sz="2200" dirty="0"/>
           </a:p>
@@ -1454,7 +1364,7 @@
               <a:buNone/>
             </a:pPr>
             <a:r>
-              <a:rPr lang="en-US" sz="2000" dirty="0">
+              <a:rPr lang="en-US" sz="2300" dirty="0">
                 <a:solidFill>
                   <a:srgbClr val="1C1C1C"/>
                 </a:solidFill>
@@ -1464,7 +1374,7 @@
               </a:rPr>
               <a:t>Conventional QB metrics like passer rating collapse multidimensional playing styles into a single value. This study asks: Can K-means clustering identify distinct, interpretable archetypes from NFL performance?</a:t>
             </a:r>
-            <a:endParaRPr lang="en-US" sz="2000" dirty="0"/>
+            <a:endParaRPr lang="en-US" sz="2300" dirty="0"/>
           </a:p>
         </p:txBody>
       </p:sp>
@@ -1667,7 +1577,7 @@
               <a:buNone/>
             </a:pPr>
             <a:r>
-              <a:rPr lang="en-US" sz="1700" dirty="0">
+              <a:rPr lang="en-US" sz="2000" b="1" dirty="0">
                 <a:solidFill>
                   <a:srgbClr val="5A6A7A"/>
                 </a:solidFill>
@@ -1677,7 +1587,7 @@
               </a:rPr>
               <a:t>QB-Seasons</a:t>
             </a:r>
-            <a:endParaRPr lang="en-US" sz="1700" dirty="0"/>
+            <a:endParaRPr lang="en-US" sz="2000" b="1" dirty="0"/>
           </a:p>
         </p:txBody>
       </p:sp>
@@ -1777,7 +1687,7 @@
               <a:buNone/>
             </a:pPr>
             <a:r>
-              <a:rPr lang="en-US" sz="1700" dirty="0">
+              <a:rPr lang="en-US" sz="2000" b="1" dirty="0">
                 <a:solidFill>
                   <a:srgbClr val="5A6A7A"/>
                 </a:solidFill>
@@ -1787,7 +1697,7 @@
               </a:rPr>
               <a:t>NFL Seasons</a:t>
             </a:r>
-            <a:endParaRPr lang="en-US" sz="1700" dirty="0"/>
+            <a:endParaRPr lang="en-US" sz="2000" b="1" dirty="0"/>
           </a:p>
         </p:txBody>
       </p:sp>
@@ -1887,7 +1797,7 @@
               <a:buNone/>
             </a:pPr>
             <a:r>
-              <a:rPr lang="en-US" sz="1700" dirty="0">
+              <a:rPr lang="en-US" sz="2000" b="1" dirty="0">
                 <a:solidFill>
                   <a:srgbClr val="5A6A7A"/>
                 </a:solidFill>
@@ -1897,7 +1807,7 @@
               </a:rPr>
               <a:t>Pass/Rush Att.</a:t>
             </a:r>
-            <a:endParaRPr lang="en-US" sz="1700" dirty="0"/>
+            <a:endParaRPr lang="en-US" sz="2000" b="1" dirty="0"/>
           </a:p>
         </p:txBody>
       </p:sp>
@@ -1926,7 +1836,7 @@
               <a:buNone/>
             </a:pPr>
             <a:r>
-              <a:rPr lang="en-US" sz="1800" dirty="0">
+              <a:rPr lang="en-US" sz="2000" dirty="0">
                 <a:solidFill>
                   <a:srgbClr val="5A6A7A"/>
                 </a:solidFill>
@@ -1936,7 +1846,7 @@
               </a:rPr>
               <a:t>Source: Pro Football Reference. Merged passing &amp; rushing season stats; mid-season trades handled via totals rows. Missing QBR imputed with mean; longest rush with median.</a:t>
             </a:r>
-            <a:endParaRPr lang="en-US" sz="1800" dirty="0"/>
+            <a:endParaRPr lang="en-US" sz="2000" dirty="0"/>
           </a:p>
         </p:txBody>
       </p:sp>
@@ -2938,77 +2848,13 @@
       </p:sp>
       <p:sp>
         <p:nvSpPr>
-          <p:cNvPr id="53" name="Shape 51"/>
-          <p:cNvSpPr/>
-          <p:nvPr/>
-        </p:nvSpPr>
-        <p:spPr>
-          <a:xfrm>
-            <a:off x="457200" y="17830800"/>
-            <a:ext cx="8138160" cy="658368"/>
-          </a:xfrm>
-          <a:prstGeom prst="rect">
-            <a:avLst/>
-          </a:prstGeom>
-          <a:solidFill>
-            <a:srgbClr val="1A3A5C"/>
-          </a:solidFill>
-          <a:ln w="12700">
-            <a:solidFill>
-              <a:srgbClr val="1A3A5C"/>
-            </a:solidFill>
-            <a:prstDash val="solid"/>
-          </a:ln>
-        </p:spPr>
-        <p:txBody>
-          <a:bodyPr/>
-          <a:lstStyle/>
-          <a:p>
-            <a:endParaRPr lang="en-US"/>
-          </a:p>
-        </p:txBody>
-      </p:sp>
-      <p:sp>
-        <p:nvSpPr>
-          <p:cNvPr id="54" name="Shape 52"/>
-          <p:cNvSpPr/>
-          <p:nvPr/>
-        </p:nvSpPr>
-        <p:spPr>
-          <a:xfrm>
-            <a:off x="457200" y="17830800"/>
-            <a:ext cx="128016" cy="658368"/>
-          </a:xfrm>
-          <a:prstGeom prst="rect">
-            <a:avLst/>
-          </a:prstGeom>
-          <a:solidFill>
-            <a:srgbClr val="F4A620"/>
-          </a:solidFill>
-          <a:ln w="12700">
-            <a:solidFill>
-              <a:srgbClr val="F4A620"/>
-            </a:solidFill>
-            <a:prstDash val="solid"/>
-          </a:ln>
-        </p:spPr>
-        <p:txBody>
-          <a:bodyPr/>
-          <a:lstStyle/>
-          <a:p>
-            <a:endParaRPr lang="en-US"/>
-          </a:p>
-        </p:txBody>
-      </p:sp>
-      <p:sp>
-        <p:nvSpPr>
           <p:cNvPr id="55" name="Text 53"/>
           <p:cNvSpPr/>
           <p:nvPr/>
         </p:nvSpPr>
         <p:spPr>
           <a:xfrm>
-            <a:off x="685800" y="17830800"/>
+            <a:off x="21282660" y="18114264"/>
             <a:ext cx="7909560" cy="658368"/>
           </a:xfrm>
           <a:prstGeom prst="rect">
@@ -3047,7 +2893,7 @@
         </p:nvSpPr>
         <p:spPr>
           <a:xfrm>
-            <a:off x="3063240" y="18608040"/>
+            <a:off x="23463504" y="18370296"/>
             <a:ext cx="5394960" cy="2286000"/>
           </a:xfrm>
           <a:prstGeom prst="rect">
@@ -3063,6 +2909,17 @@
             <a:pPr marL="0" indent="0">
               <a:buNone/>
             </a:pPr>
+            <a:r>
+              <a:rPr lang="en-US" sz="2300" b="1" dirty="0">
+                <a:solidFill>
+                  <a:srgbClr val="1A3A5C"/>
+                </a:solidFill>
+                <a:latin typeface="Calibri" pitchFamily="34" charset="0"/>
+                <a:ea typeface="Calibri" pitchFamily="34" charset="-122"/>
+                <a:cs typeface="Calibri" pitchFamily="34" charset="-120"/>
+              </a:rPr>
+              <a:t>GitHub Repository</a:t>
+            </a:r>
             <a:r>
               <a:rPr lang="en-US" sz="2000" b="1" dirty="0">
                 <a:solidFill>
@@ -3072,7 +2929,7 @@
                 <a:ea typeface="Calibri" pitchFamily="34" charset="-122"/>
                 <a:cs typeface="Calibri" pitchFamily="34" charset="-120"/>
               </a:rPr>
-              <a:t>GitHub Repository
+              <a:t>
 </a:t>
             </a:r>
             <a:endParaRPr lang="en-US" sz="2000" dirty="0"/>
@@ -3081,6 +2938,18 @@
             <a:pPr marL="0" indent="0">
               <a:buNone/>
             </a:pPr>
+            <a:r>
+              <a:rPr lang="en-US" sz="2000" dirty="0">
+                <a:solidFill>
+                  <a:srgbClr val="1C1C1C"/>
+                </a:solidFill>
+                <a:latin typeface="Calibri" pitchFamily="34" charset="0"/>
+                <a:ea typeface="Calibri" pitchFamily="34" charset="-122"/>
+                <a:cs typeface="Calibri" pitchFamily="34" charset="-120"/>
+              </a:rPr>
+              <a:t>github.com/ShubhanTamhane1/
+nfl-qb-archetypes</a:t>
+            </a:r>
             <a:r>
               <a:rPr lang="en-US" sz="1700" dirty="0">
                 <a:solidFill>
@@ -3090,8 +2959,7 @@
                 <a:ea typeface="Calibri" pitchFamily="34" charset="-122"/>
                 <a:cs typeface="Calibri" pitchFamily="34" charset="-120"/>
               </a:rPr>
-              <a:t>github.com/ShubhanTamhane1/
-nfl-qb-archetypes
+              <a:t>
 </a:t>
             </a:r>
             <a:endParaRPr lang="en-US" sz="2000" dirty="0"/>
@@ -3100,6 +2968,17 @@
             <a:pPr marL="0" indent="0">
               <a:buNone/>
             </a:pPr>
+            <a:r>
+              <a:rPr lang="en-US" sz="2000" i="1" dirty="0">
+                <a:solidFill>
+                  <a:srgbClr val="5A6A7A"/>
+                </a:solidFill>
+                <a:latin typeface="Calibri" pitchFamily="34" charset="0"/>
+                <a:ea typeface="Calibri" pitchFamily="34" charset="-122"/>
+                <a:cs typeface="Calibri" pitchFamily="34" charset="-120"/>
+              </a:rPr>
+              <a:t>Scan for source code, notebook, and data pipeline</a:t>
+            </a:r>
             <a:r>
               <a:rPr lang="en-US" sz="1600" i="1" dirty="0">
                 <a:solidFill>
@@ -3109,7 +2988,7 @@
                 <a:ea typeface="Calibri" pitchFamily="34" charset="-122"/>
                 <a:cs typeface="Calibri" pitchFamily="34" charset="-120"/>
               </a:rPr>
-              <a:t>Scan for source code, notebook, and data pipeline.</a:t>
+              <a:t>.</a:t>
             </a:r>
             <a:endParaRPr lang="en-US" sz="2000" dirty="0"/>
           </a:p>
@@ -3218,29 +3097,6 @@
           </a:p>
         </p:txBody>
       </p:sp>
-      <p:pic>
-        <p:nvPicPr>
-          <p:cNvPr id="61" name="Image 1" descr="preencoded.png"/>
-          <p:cNvPicPr>
-            <a:picLocks noChangeAspect="1"/>
-          </p:cNvPicPr>
-          <p:nvPr/>
-        </p:nvPicPr>
-        <p:blipFill>
-          <a:blip r:embed="rId3"/>
-          <a:srcRect/>
-          <a:stretch/>
-        </p:blipFill>
-        <p:spPr>
-          <a:xfrm>
-            <a:off x="9281160" y="3776472"/>
-            <a:ext cx="10515600" cy="6583680"/>
-          </a:xfrm>
-          <a:prstGeom prst="rect">
-            <a:avLst/>
-          </a:prstGeom>
-        </p:spPr>
-      </p:pic>
       <p:sp>
         <p:nvSpPr>
           <p:cNvPr id="62" name="Text 58"/>
@@ -3288,7 +3144,7 @@
         </p:nvSpPr>
         <p:spPr>
           <a:xfrm>
-            <a:off x="9281160" y="11640312"/>
+            <a:off x="9061704" y="11713464"/>
             <a:ext cx="10515600" cy="658368"/>
           </a:xfrm>
           <a:prstGeom prst="rect">
@@ -3320,7 +3176,7 @@
         </p:nvSpPr>
         <p:spPr>
           <a:xfrm>
-            <a:off x="9281160" y="11640312"/>
+            <a:off x="9061704" y="11713464"/>
             <a:ext cx="128016" cy="658368"/>
           </a:xfrm>
           <a:prstGeom prst="rect">
@@ -3352,7 +3208,7 @@
         </p:nvSpPr>
         <p:spPr>
           <a:xfrm>
-            <a:off x="9509760" y="11640312"/>
+            <a:off x="9290304" y="11713464"/>
             <a:ext cx="10287000" cy="658368"/>
           </a:xfrm>
           <a:prstGeom prst="rect">
@@ -3392,14 +3248,14 @@
           <p:nvPr>
             <p:extLst>
               <p:ext uri="{D42A27DB-BD31-4B8C-83A1-F6EECF244321}">
-                <p14:modId xmlns:p14="http://schemas.microsoft.com/office/powerpoint/2010/main" val="1579011935"/>
+                <p14:modId xmlns:p14="http://schemas.microsoft.com/office/powerpoint/2010/main" val="492658536"/>
               </p:ext>
             </p:extLst>
           </p:nvPr>
         </p:nvGraphicFramePr>
         <p:xfrm>
-          <a:off x="9281160" y="12417552"/>
-          <a:ext cx="11887200" cy="3429000"/>
+          <a:off x="9006840" y="12487221"/>
+          <a:ext cx="11064240" cy="3429000"/>
         </p:xfrm>
         <a:graphic>
           <a:graphicData uri="http://schemas.openxmlformats.org/drawingml/2006/table">
@@ -3455,13 +3311,6 @@
                     </a:ext>
                   </a:extLst>
                 </a:gridCol>
-                <a:gridCol w="822960">
-                  <a:extLst>
-                    <a:ext uri="{9D8B030D-6E8A-4147-A177-3AD203B41FA5}">
-                      <a16:colId xmlns:a16="http://schemas.microsoft.com/office/drawing/2014/main" val="20007"/>
-                    </a:ext>
-                  </a:extLst>
-                </a:gridCol>
               </a:tblGrid>
               <a:tr h="685800">
                 <a:tc>
@@ -3890,74 +3739,6 @@
                           <a:cs typeface="Calibri" pitchFamily="34" charset="-120"/>
                         </a:rPr>
                         <a:t>Rush TD</a:t>
-                      </a:r>
-                      <a:endParaRPr lang="en-US" sz="2000" dirty="0">
-                        <a:latin typeface="Calibri" charset="0"/>
-                        <a:ea typeface="Calibri" charset="0"/>
-                        <a:cs typeface="Calibri" charset="0"/>
-                      </a:endParaRPr>
-                    </a:p>
-                  </a:txBody>
-                  <a:tcPr>
-                    <a:lnL w="12700" cap="flat" cmpd="sng" algn="ctr">
-                      <a:solidFill>
-                        <a:srgbClr val="C8D6E5"/>
-                      </a:solidFill>
-                      <a:prstDash val="solid"/>
-                      <a:round/>
-                      <a:headEnd type="none" w="med" len="med"/>
-                      <a:tailEnd type="none" w="med" len="med"/>
-                    </a:lnL>
-                    <a:lnR w="12700" cap="flat" cmpd="sng" algn="ctr">
-                      <a:solidFill>
-                        <a:srgbClr val="C8D6E5"/>
-                      </a:solidFill>
-                      <a:prstDash val="solid"/>
-                      <a:round/>
-                      <a:headEnd type="none" w="med" len="med"/>
-                      <a:tailEnd type="none" w="med" len="med"/>
-                    </a:lnR>
-                    <a:lnT w="12700" cap="flat" cmpd="sng" algn="ctr">
-                      <a:solidFill>
-                        <a:srgbClr val="C8D6E5"/>
-                      </a:solidFill>
-                      <a:prstDash val="solid"/>
-                      <a:round/>
-                      <a:headEnd type="none" w="med" len="med"/>
-                      <a:tailEnd type="none" w="med" len="med"/>
-                    </a:lnT>
-                    <a:lnB w="12700" cap="flat" cmpd="sng" algn="ctr">
-                      <a:solidFill>
-                        <a:srgbClr val="C8D6E5"/>
-                      </a:solidFill>
-                      <a:prstDash val="solid"/>
-                      <a:round/>
-                      <a:headEnd type="none" w="med" len="med"/>
-                      <a:tailEnd type="none" w="med" len="med"/>
-                    </a:lnB>
-                    <a:solidFill>
-                      <a:srgbClr val="1A3A5C"/>
-                    </a:solidFill>
-                  </a:tcPr>
-                </a:tc>
-                <a:tc>
-                  <a:txBody>
-                    <a:bodyPr/>
-                    <a:lstStyle/>
-                    <a:p>
-                      <a:pPr marL="0" indent="0" algn="ctr">
-                        <a:buNone/>
-                      </a:pPr>
-                      <a:r>
-                        <a:rPr lang="en-US" sz="2000" b="1" dirty="0">
-                          <a:solidFill>
-                            <a:srgbClr val="FFFFFF"/>
-                          </a:solidFill>
-                          <a:latin typeface="Calibri" pitchFamily="34" charset="0"/>
-                          <a:ea typeface="Calibri" pitchFamily="34" charset="-122"/>
-                          <a:cs typeface="Calibri" pitchFamily="34" charset="-120"/>
-                        </a:rPr>
-                        <a:t>n</a:t>
                       </a:r>
                       <a:endParaRPr lang="en-US" sz="2000" dirty="0">
                         <a:latin typeface="Calibri" charset="0"/>
@@ -4473,71 +4254,6 @@
                     </a:lnB>
                   </a:tcPr>
                 </a:tc>
-                <a:tc>
-                  <a:txBody>
-                    <a:bodyPr/>
-                    <a:lstStyle/>
-                    <a:p>
-                      <a:pPr marL="0" indent="0" algn="ctr">
-                        <a:buNone/>
-                      </a:pPr>
-                      <a:r>
-                        <a:rPr lang="en-US" sz="2000" dirty="0">
-                          <a:solidFill>
-                            <a:srgbClr val="5A6A7A"/>
-                          </a:solidFill>
-                          <a:latin typeface="Calibri" pitchFamily="34" charset="0"/>
-                          <a:ea typeface="Calibri" pitchFamily="34" charset="-122"/>
-                          <a:cs typeface="Calibri" pitchFamily="34" charset="-120"/>
-                        </a:rPr>
-                        <a:t>85</a:t>
-                      </a:r>
-                      <a:endParaRPr lang="en-US" sz="2000" dirty="0">
-                        <a:latin typeface="Calibri" charset="0"/>
-                        <a:ea typeface="Calibri" charset="0"/>
-                        <a:cs typeface="Calibri" charset="0"/>
-                      </a:endParaRPr>
-                    </a:p>
-                  </a:txBody>
-                  <a:tcPr>
-                    <a:lnL w="12700" cap="flat" cmpd="sng" algn="ctr">
-                      <a:solidFill>
-                        <a:srgbClr val="C8D6E5"/>
-                      </a:solidFill>
-                      <a:prstDash val="solid"/>
-                      <a:round/>
-                      <a:headEnd type="none" w="med" len="med"/>
-                      <a:tailEnd type="none" w="med" len="med"/>
-                    </a:lnL>
-                    <a:lnR w="12700" cap="flat" cmpd="sng" algn="ctr">
-                      <a:solidFill>
-                        <a:srgbClr val="C8D6E5"/>
-                      </a:solidFill>
-                      <a:prstDash val="solid"/>
-                      <a:round/>
-                      <a:headEnd type="none" w="med" len="med"/>
-                      <a:tailEnd type="none" w="med" len="med"/>
-                    </a:lnR>
-                    <a:lnT w="12700" cap="flat" cmpd="sng" algn="ctr">
-                      <a:solidFill>
-                        <a:srgbClr val="C8D6E5"/>
-                      </a:solidFill>
-                      <a:prstDash val="solid"/>
-                      <a:round/>
-                      <a:headEnd type="none" w="med" len="med"/>
-                      <a:tailEnd type="none" w="med" len="med"/>
-                    </a:lnT>
-                    <a:lnB w="12700" cap="flat" cmpd="sng" algn="ctr">
-                      <a:solidFill>
-                        <a:srgbClr val="C8D6E5"/>
-                      </a:solidFill>
-                      <a:prstDash val="solid"/>
-                      <a:round/>
-                      <a:headEnd type="none" w="med" len="med"/>
-                      <a:tailEnd type="none" w="med" len="med"/>
-                    </a:lnB>
-                  </a:tcPr>
-                </a:tc>
                 <a:extLst>
                   <a:ext uri="{0D108BD9-81ED-4DB2-BD59-A6C34878D82A}">
                     <a16:rowId xmlns:a16="http://schemas.microsoft.com/office/drawing/2014/main" val="10001"/>
@@ -4956,71 +4672,6 @@
                           <a:cs typeface="Calibri" pitchFamily="34" charset="-120"/>
                         </a:rPr>
                         <a:t>0.9</a:t>
-                      </a:r>
-                      <a:endParaRPr lang="en-US" sz="2000" dirty="0">
-                        <a:latin typeface="Calibri" charset="0"/>
-                        <a:ea typeface="Calibri" charset="0"/>
-                        <a:cs typeface="Calibri" charset="0"/>
-                      </a:endParaRPr>
-                    </a:p>
-                  </a:txBody>
-                  <a:tcPr>
-                    <a:lnL w="12700" cap="flat" cmpd="sng" algn="ctr">
-                      <a:solidFill>
-                        <a:srgbClr val="C8D6E5"/>
-                      </a:solidFill>
-                      <a:prstDash val="solid"/>
-                      <a:round/>
-                      <a:headEnd type="none" w="med" len="med"/>
-                      <a:tailEnd type="none" w="med" len="med"/>
-                    </a:lnL>
-                    <a:lnR w="12700" cap="flat" cmpd="sng" algn="ctr">
-                      <a:solidFill>
-                        <a:srgbClr val="C8D6E5"/>
-                      </a:solidFill>
-                      <a:prstDash val="solid"/>
-                      <a:round/>
-                      <a:headEnd type="none" w="med" len="med"/>
-                      <a:tailEnd type="none" w="med" len="med"/>
-                    </a:lnR>
-                    <a:lnT w="12700" cap="flat" cmpd="sng" algn="ctr">
-                      <a:solidFill>
-                        <a:srgbClr val="C8D6E5"/>
-                      </a:solidFill>
-                      <a:prstDash val="solid"/>
-                      <a:round/>
-                      <a:headEnd type="none" w="med" len="med"/>
-                      <a:tailEnd type="none" w="med" len="med"/>
-                    </a:lnT>
-                    <a:lnB w="12700" cap="flat" cmpd="sng" algn="ctr">
-                      <a:solidFill>
-                        <a:srgbClr val="C8D6E5"/>
-                      </a:solidFill>
-                      <a:prstDash val="solid"/>
-                      <a:round/>
-                      <a:headEnd type="none" w="med" len="med"/>
-                      <a:tailEnd type="none" w="med" len="med"/>
-                    </a:lnB>
-                  </a:tcPr>
-                </a:tc>
-                <a:tc>
-                  <a:txBody>
-                    <a:bodyPr/>
-                    <a:lstStyle/>
-                    <a:p>
-                      <a:pPr marL="0" indent="0" algn="ctr">
-                        <a:buNone/>
-                      </a:pPr>
-                      <a:r>
-                        <a:rPr lang="en-US" sz="2000" dirty="0">
-                          <a:solidFill>
-                            <a:srgbClr val="5A6A7A"/>
-                          </a:solidFill>
-                          <a:latin typeface="Calibri" pitchFamily="34" charset="0"/>
-                          <a:ea typeface="Calibri" pitchFamily="34" charset="-122"/>
-                          <a:cs typeface="Calibri" pitchFamily="34" charset="-120"/>
-                        </a:rPr>
-                        <a:t>48</a:t>
                       </a:r>
                       <a:endParaRPr lang="en-US" sz="2000" dirty="0">
                         <a:latin typeface="Calibri" charset="0"/>
@@ -5282,9 +4933,9 @@
                         <a:buNone/>
                       </a:pPr>
                       <a:r>
-                        <a:rPr lang="en-US" sz="2000" b="1" dirty="0">
+                        <a:rPr lang="en-US" sz="2000" b="0" dirty="0">
                           <a:solidFill>
-                            <a:srgbClr val="B71C1C"/>
+                            <a:schemeClr val="tx1"/>
                           </a:solidFill>
                           <a:latin typeface="Calibri" pitchFamily="34" charset="0"/>
                           <a:ea typeface="Calibri" pitchFamily="34" charset="-122"/>
@@ -5292,7 +4943,10 @@
                         </a:rPr>
                         <a:t>10.8</a:t>
                       </a:r>
-                      <a:endParaRPr lang="en-US" sz="2000" dirty="0">
+                      <a:endParaRPr lang="en-US" sz="2000" b="0" dirty="0">
+                        <a:solidFill>
+                          <a:schemeClr val="tx1"/>
+                        </a:solidFill>
                         <a:latin typeface="Calibri" charset="0"/>
                         <a:ea typeface="Calibri" charset="0"/>
                         <a:cs typeface="Calibri" charset="0"/>
@@ -5486,71 +5140,6 @@
                           <a:cs typeface="Calibri" pitchFamily="34" charset="-120"/>
                         </a:rPr>
                         <a:t>1.2</a:t>
-                      </a:r>
-                      <a:endParaRPr lang="en-US" sz="2000" dirty="0">
-                        <a:latin typeface="Calibri" charset="0"/>
-                        <a:ea typeface="Calibri" charset="0"/>
-                        <a:cs typeface="Calibri" charset="0"/>
-                      </a:endParaRPr>
-                    </a:p>
-                  </a:txBody>
-                  <a:tcPr>
-                    <a:lnL w="12700" cap="flat" cmpd="sng" algn="ctr">
-                      <a:solidFill>
-                        <a:srgbClr val="C8D6E5"/>
-                      </a:solidFill>
-                      <a:prstDash val="solid"/>
-                      <a:round/>
-                      <a:headEnd type="none" w="med" len="med"/>
-                      <a:tailEnd type="none" w="med" len="med"/>
-                    </a:lnL>
-                    <a:lnR w="12700" cap="flat" cmpd="sng" algn="ctr">
-                      <a:solidFill>
-                        <a:srgbClr val="C8D6E5"/>
-                      </a:solidFill>
-                      <a:prstDash val="solid"/>
-                      <a:round/>
-                      <a:headEnd type="none" w="med" len="med"/>
-                      <a:tailEnd type="none" w="med" len="med"/>
-                    </a:lnR>
-                    <a:lnT w="12700" cap="flat" cmpd="sng" algn="ctr">
-                      <a:solidFill>
-                        <a:srgbClr val="C8D6E5"/>
-                      </a:solidFill>
-                      <a:prstDash val="solid"/>
-                      <a:round/>
-                      <a:headEnd type="none" w="med" len="med"/>
-                      <a:tailEnd type="none" w="med" len="med"/>
-                    </a:lnT>
-                    <a:lnB w="12700" cap="flat" cmpd="sng" algn="ctr">
-                      <a:solidFill>
-                        <a:srgbClr val="C8D6E5"/>
-                      </a:solidFill>
-                      <a:prstDash val="solid"/>
-                      <a:round/>
-                      <a:headEnd type="none" w="med" len="med"/>
-                      <a:tailEnd type="none" w="med" len="med"/>
-                    </a:lnB>
-                  </a:tcPr>
-                </a:tc>
-                <a:tc>
-                  <a:txBody>
-                    <a:bodyPr/>
-                    <a:lstStyle/>
-                    <a:p>
-                      <a:pPr marL="0" indent="0" algn="ctr">
-                        <a:buNone/>
-                      </a:pPr>
-                      <a:r>
-                        <a:rPr lang="en-US" sz="2000" dirty="0">
-                          <a:solidFill>
-                            <a:srgbClr val="5A6A7A"/>
-                          </a:solidFill>
-                          <a:latin typeface="Calibri" pitchFamily="34" charset="0"/>
-                          <a:ea typeface="Calibri" pitchFamily="34" charset="-122"/>
-                          <a:cs typeface="Calibri" pitchFamily="34" charset="-120"/>
-                        </a:rPr>
-                        <a:t>47</a:t>
                       </a:r>
                       <a:endParaRPr lang="en-US" sz="2000" dirty="0">
                         <a:latin typeface="Calibri" charset="0"/>
@@ -6063,71 +5652,6 @@
                     </a:lnB>
                   </a:tcPr>
                 </a:tc>
-                <a:tc>
-                  <a:txBody>
-                    <a:bodyPr/>
-                    <a:lstStyle/>
-                    <a:p>
-                      <a:pPr marL="0" indent="0" algn="ctr">
-                        <a:buNone/>
-                      </a:pPr>
-                      <a:r>
-                        <a:rPr lang="en-US" sz="2000" dirty="0">
-                          <a:solidFill>
-                            <a:srgbClr val="5A6A7A"/>
-                          </a:solidFill>
-                          <a:latin typeface="Calibri" pitchFamily="34" charset="0"/>
-                          <a:ea typeface="Calibri" pitchFamily="34" charset="-122"/>
-                          <a:cs typeface="Calibri" pitchFamily="34" charset="-120"/>
-                        </a:rPr>
-                        <a:t>25</a:t>
-                      </a:r>
-                      <a:endParaRPr lang="en-US" sz="2000" dirty="0">
-                        <a:latin typeface="Calibri" charset="0"/>
-                        <a:ea typeface="Calibri" charset="0"/>
-                        <a:cs typeface="Calibri" charset="0"/>
-                      </a:endParaRPr>
-                    </a:p>
-                  </a:txBody>
-                  <a:tcPr>
-                    <a:lnL w="12700" cap="flat" cmpd="sng" algn="ctr">
-                      <a:solidFill>
-                        <a:srgbClr val="C8D6E5"/>
-                      </a:solidFill>
-                      <a:prstDash val="solid"/>
-                      <a:round/>
-                      <a:headEnd type="none" w="med" len="med"/>
-                      <a:tailEnd type="none" w="med" len="med"/>
-                    </a:lnL>
-                    <a:lnR w="12700" cap="flat" cmpd="sng" algn="ctr">
-                      <a:solidFill>
-                        <a:srgbClr val="C8D6E5"/>
-                      </a:solidFill>
-                      <a:prstDash val="solid"/>
-                      <a:round/>
-                      <a:headEnd type="none" w="med" len="med"/>
-                      <a:tailEnd type="none" w="med" len="med"/>
-                    </a:lnR>
-                    <a:lnT w="12700" cap="flat" cmpd="sng" algn="ctr">
-                      <a:solidFill>
-                        <a:srgbClr val="C8D6E5"/>
-                      </a:solidFill>
-                      <a:prstDash val="solid"/>
-                      <a:round/>
-                      <a:headEnd type="none" w="med" len="med"/>
-                      <a:tailEnd type="none" w="med" len="med"/>
-                    </a:lnT>
-                    <a:lnB w="12700" cap="flat" cmpd="sng" algn="ctr">
-                      <a:solidFill>
-                        <a:srgbClr val="C8D6E5"/>
-                      </a:solidFill>
-                      <a:prstDash val="solid"/>
-                      <a:round/>
-                      <a:headEnd type="none" w="med" len="med"/>
-                      <a:tailEnd type="none" w="med" len="med"/>
-                    </a:lnB>
-                  </a:tcPr>
-                </a:tc>
                 <a:extLst>
                   <a:ext uri="{0D108BD9-81ED-4DB2-BD59-A6C34878D82A}">
                     <a16:rowId xmlns:a16="http://schemas.microsoft.com/office/drawing/2014/main" val="10004"/>
@@ -6349,7 +5873,7 @@
                 <a:ea typeface="Calibri" pitchFamily="34" charset="-122"/>
                 <a:cs typeface="Calibri" pitchFamily="34" charset="-120"/>
               </a:rPr>
-              <a:t>Patrick Mahomes, Dak Prescott, Joe Burrow, Tom Brady, Aaron Rodgers</a:t>
+              <a:t>Patrick Mahomes (KC), Dak Prescott (DAL), Joe Burrow (CIN), Tom Brady (NE)</a:t>
             </a:r>
             <a:endParaRPr lang="en-US" sz="2000" dirty="0"/>
           </a:p>
@@ -6463,7 +5987,7 @@
                 <a:ea typeface="Calibri" pitchFamily="34" charset="-122"/>
                 <a:cs typeface="Calibri" pitchFamily="34" charset="-120"/>
               </a:rPr>
-              <a:t>Mac Jones, Devlin Hodges, Early Jalen Hurts (2020)</a:t>
+              <a:t>Mac Jones (NE), Devlin Hodges (PIT) , Early Jalen Hurts (2020, PHI)</a:t>
             </a:r>
             <a:endParaRPr lang="en-US" sz="2000" dirty="0"/>
           </a:p>
@@ -6577,7 +6101,7 @@
                 <a:ea typeface="Calibri" pitchFamily="34" charset="-122"/>
                 <a:cs typeface="Calibri" pitchFamily="34" charset="-120"/>
               </a:rPr>
-              <a:t>Justin Herbert, Taylor Heinicke, Sam Howell, Josh Johnson</a:t>
+              <a:t>Justin Herbert (LAC), Taylor Heinicke (WAS) , Sam Howell (WAS) , Josh Johnson (DEN)</a:t>
             </a:r>
             <a:endParaRPr lang="en-US" sz="2000" dirty="0"/>
           </a:p>
@@ -6691,7 +6215,7 @@
                 <a:ea typeface="Calibri" pitchFamily="34" charset="-122"/>
                 <a:cs typeface="Calibri" pitchFamily="34" charset="-120"/>
               </a:rPr>
-              <a:t>Lamar Jackson, Kyler Murray, Josh Allen, Jalen Hurts</a:t>
+              <a:t>Lamar Jackson (BAL) , Kyler Murray (ARI) , Josh Allen (BUF) , Jalen Hurts (PHI)</a:t>
             </a:r>
             <a:endParaRPr lang="en-US" sz="2000" dirty="0"/>
           </a:p>
@@ -6705,7 +6229,7 @@
         </p:nvSpPr>
         <p:spPr>
           <a:xfrm>
-            <a:off x="20482560" y="2999232"/>
+            <a:off x="20436840" y="3023616"/>
             <a:ext cx="11978640" cy="658368"/>
           </a:xfrm>
           <a:prstGeom prst="rect">
@@ -6737,7 +6261,7 @@
         </p:nvSpPr>
         <p:spPr>
           <a:xfrm>
-            <a:off x="20482560" y="2999232"/>
+            <a:off x="20436840" y="3023616"/>
             <a:ext cx="128016" cy="658368"/>
           </a:xfrm>
           <a:prstGeom prst="rect">
@@ -6924,7 +6448,7 @@
               <a:buNone/>
             </a:pPr>
             <a:r>
-              <a:rPr lang="en-US" sz="1700" i="1" dirty="0">
+              <a:rPr lang="en-US" sz="2000" i="1" dirty="0">
                 <a:solidFill>
                   <a:srgbClr val="5A6A7A"/>
                 </a:solidFill>
@@ -6934,71 +6458,7 @@
               </a:rPr>
               <a:t>Silhouette score at k=4: 0.208  |  Elbow + silhouette both confirmed k=4  |  Tukey HSD run on all 10 metrics</a:t>
             </a:r>
-            <a:endParaRPr lang="en-US" sz="1700" dirty="0"/>
-          </a:p>
-        </p:txBody>
-      </p:sp>
-      <p:sp>
-        <p:nvSpPr>
-          <p:cNvPr id="88" name="Shape 83"/>
-          <p:cNvSpPr/>
-          <p:nvPr/>
-        </p:nvSpPr>
-        <p:spPr>
-          <a:xfrm>
-            <a:off x="20482560" y="5650992"/>
-            <a:ext cx="11978640" cy="658368"/>
-          </a:xfrm>
-          <a:prstGeom prst="rect">
-            <a:avLst/>
-          </a:prstGeom>
-          <a:solidFill>
-            <a:srgbClr val="1A3A5C"/>
-          </a:solidFill>
-          <a:ln w="12700">
-            <a:solidFill>
-              <a:srgbClr val="1A3A5C"/>
-            </a:solidFill>
-            <a:prstDash val="solid"/>
-          </a:ln>
-        </p:spPr>
-        <p:txBody>
-          <a:bodyPr/>
-          <a:lstStyle/>
-          <a:p>
-            <a:endParaRPr lang="en-US"/>
-          </a:p>
-        </p:txBody>
-      </p:sp>
-      <p:sp>
-        <p:nvSpPr>
-          <p:cNvPr id="89" name="Shape 84"/>
-          <p:cNvSpPr/>
-          <p:nvPr/>
-        </p:nvSpPr>
-        <p:spPr>
-          <a:xfrm>
-            <a:off x="20482560" y="5650992"/>
-            <a:ext cx="128016" cy="658368"/>
-          </a:xfrm>
-          <a:prstGeom prst="rect">
-            <a:avLst/>
-          </a:prstGeom>
-          <a:solidFill>
-            <a:srgbClr val="F4A620"/>
-          </a:solidFill>
-          <a:ln w="12700">
-            <a:solidFill>
-              <a:srgbClr val="F4A620"/>
-            </a:solidFill>
-            <a:prstDash val="solid"/>
-          </a:ln>
-        </p:spPr>
-        <p:txBody>
-          <a:bodyPr/>
-          <a:lstStyle/>
-          <a:p>
-            <a:endParaRPr lang="en-US"/>
+            <a:endParaRPr lang="en-US" sz="2000" dirty="0"/>
           </a:p>
         </p:txBody>
       </p:sp>
@@ -7041,1321 +6501,6 @@
           </a:p>
         </p:txBody>
       </p:sp>
-      <p:graphicFrame>
-        <p:nvGraphicFramePr>
-          <p:cNvPr id="91" name="Table 1"/>
-          <p:cNvGraphicFramePr>
-            <a:graphicFrameLocks noGrp="1"/>
-          </p:cNvGraphicFramePr>
-          <p:nvPr>
-            <p:extLst>
-              <p:ext uri="{D42A27DB-BD31-4B8C-83A1-F6EECF244321}">
-                <p14:modId xmlns:p14="http://schemas.microsoft.com/office/powerpoint/2010/main" val="1579011935"/>
-              </p:ext>
-            </p:extLst>
-          </p:nvPr>
-        </p:nvGraphicFramePr>
-        <p:xfrm>
-          <a:off x="20482560" y="6428232"/>
-          <a:ext cx="8686800" cy="3730752"/>
-        </p:xfrm>
-        <a:graphic>
-          <a:graphicData uri="http://schemas.openxmlformats.org/drawingml/2006/table">
-            <a:tbl>
-              <a:tblPr/>
-              <a:tblGrid>
-                <a:gridCol w="5486400">
-                  <a:extLst>
-                    <a:ext uri="{9D8B030D-6E8A-4147-A177-3AD203B41FA5}">
-                      <a16:colId xmlns:a16="http://schemas.microsoft.com/office/drawing/2014/main" val="20000"/>
-                    </a:ext>
-                  </a:extLst>
-                </a:gridCol>
-                <a:gridCol w="1920240">
-                  <a:extLst>
-                    <a:ext uri="{9D8B030D-6E8A-4147-A177-3AD203B41FA5}">
-                      <a16:colId xmlns:a16="http://schemas.microsoft.com/office/drawing/2014/main" val="20001"/>
-                    </a:ext>
-                  </a:extLst>
-                </a:gridCol>
-                <a:gridCol w="1280160">
-                  <a:extLst>
-                    <a:ext uri="{9D8B030D-6E8A-4147-A177-3AD203B41FA5}">
-                      <a16:colId xmlns:a16="http://schemas.microsoft.com/office/drawing/2014/main" val="20002"/>
-                    </a:ext>
-                  </a:extLst>
-                </a:gridCol>
-              </a:tblGrid>
-              <a:tr h="621792">
-                <a:tc>
-                  <a:txBody>
-                    <a:bodyPr/>
-                    <a:lstStyle/>
-                    <a:p>
-                      <a:pPr marL="0" indent="0">
-                        <a:buNone/>
-                      </a:pPr>
-                      <a:r>
-                        <a:rPr lang="en-US" sz="2000" b="1" dirty="0">
-                          <a:solidFill>
-                            <a:srgbClr val="FFFFFF"/>
-                          </a:solidFill>
-                          <a:latin typeface="Calibri" pitchFamily="34" charset="0"/>
-                          <a:ea typeface="Calibri" pitchFamily="34" charset="-122"/>
-                          <a:cs typeface="Calibri" pitchFamily="34" charset="-120"/>
-                        </a:rPr>
-                        <a:t>Comparison</a:t>
-                      </a:r>
-                      <a:endParaRPr lang="en-US" sz="2000" dirty="0">
-                        <a:latin typeface="Calibri" charset="0"/>
-                        <a:ea typeface="Calibri" charset="0"/>
-                        <a:cs typeface="Calibri" charset="0"/>
-                      </a:endParaRPr>
-                    </a:p>
-                  </a:txBody>
-                  <a:tcPr>
-                    <a:lnL w="12700" cap="flat" cmpd="sng" algn="ctr">
-                      <a:solidFill>
-                        <a:srgbClr val="C8D6E5"/>
-                      </a:solidFill>
-                      <a:prstDash val="solid"/>
-                      <a:round/>
-                      <a:headEnd type="none" w="med" len="med"/>
-                      <a:tailEnd type="none" w="med" len="med"/>
-                    </a:lnL>
-                    <a:lnR w="12700" cap="flat" cmpd="sng" algn="ctr">
-                      <a:solidFill>
-                        <a:srgbClr val="C8D6E5"/>
-                      </a:solidFill>
-                      <a:prstDash val="solid"/>
-                      <a:round/>
-                      <a:headEnd type="none" w="med" len="med"/>
-                      <a:tailEnd type="none" w="med" len="med"/>
-                    </a:lnR>
-                    <a:lnT w="12700" cap="flat" cmpd="sng" algn="ctr">
-                      <a:solidFill>
-                        <a:srgbClr val="C8D6E5"/>
-                      </a:solidFill>
-                      <a:prstDash val="solid"/>
-                      <a:round/>
-                      <a:headEnd type="none" w="med" len="med"/>
-                      <a:tailEnd type="none" w="med" len="med"/>
-                    </a:lnT>
-                    <a:lnB w="12700" cap="flat" cmpd="sng" algn="ctr">
-                      <a:solidFill>
-                        <a:srgbClr val="C8D6E5"/>
-                      </a:solidFill>
-                      <a:prstDash val="solid"/>
-                      <a:round/>
-                      <a:headEnd type="none" w="med" len="med"/>
-                      <a:tailEnd type="none" w="med" len="med"/>
-                    </a:lnB>
-                    <a:solidFill>
-                      <a:srgbClr val="1A3A5C"/>
-                    </a:solidFill>
-                  </a:tcPr>
-                </a:tc>
-                <a:tc>
-                  <a:txBody>
-                    <a:bodyPr/>
-                    <a:lstStyle/>
-                    <a:p>
-                      <a:pPr marL="0" indent="0" algn="ctr">
-                        <a:buNone/>
-                      </a:pPr>
-                      <a:r>
-                        <a:rPr lang="en-US" sz="2000" b="1" dirty="0">
-                          <a:solidFill>
-                            <a:srgbClr val="FFFFFF"/>
-                          </a:solidFill>
-                          <a:latin typeface="Calibri" pitchFamily="34" charset="0"/>
-                          <a:ea typeface="Calibri" pitchFamily="34" charset="-122"/>
-                          <a:cs typeface="Calibri" pitchFamily="34" charset="-120"/>
-                        </a:rPr>
-                        <a:t>p-value</a:t>
-                      </a:r>
-                      <a:endParaRPr lang="en-US" sz="2000" dirty="0">
-                        <a:latin typeface="Calibri" charset="0"/>
-                        <a:ea typeface="Calibri" charset="0"/>
-                        <a:cs typeface="Calibri" charset="0"/>
-                      </a:endParaRPr>
-                    </a:p>
-                  </a:txBody>
-                  <a:tcPr>
-                    <a:lnL w="12700" cap="flat" cmpd="sng" algn="ctr">
-                      <a:solidFill>
-                        <a:srgbClr val="C8D6E5"/>
-                      </a:solidFill>
-                      <a:prstDash val="solid"/>
-                      <a:round/>
-                      <a:headEnd type="none" w="med" len="med"/>
-                      <a:tailEnd type="none" w="med" len="med"/>
-                    </a:lnL>
-                    <a:lnR w="12700" cap="flat" cmpd="sng" algn="ctr">
-                      <a:solidFill>
-                        <a:srgbClr val="C8D6E5"/>
-                      </a:solidFill>
-                      <a:prstDash val="solid"/>
-                      <a:round/>
-                      <a:headEnd type="none" w="med" len="med"/>
-                      <a:tailEnd type="none" w="med" len="med"/>
-                    </a:lnR>
-                    <a:lnT w="12700" cap="flat" cmpd="sng" algn="ctr">
-                      <a:solidFill>
-                        <a:srgbClr val="C8D6E5"/>
-                      </a:solidFill>
-                      <a:prstDash val="solid"/>
-                      <a:round/>
-                      <a:headEnd type="none" w="med" len="med"/>
-                      <a:tailEnd type="none" w="med" len="med"/>
-                    </a:lnT>
-                    <a:lnB w="12700" cap="flat" cmpd="sng" algn="ctr">
-                      <a:solidFill>
-                        <a:srgbClr val="C8D6E5"/>
-                      </a:solidFill>
-                      <a:prstDash val="solid"/>
-                      <a:round/>
-                      <a:headEnd type="none" w="med" len="med"/>
-                      <a:tailEnd type="none" w="med" len="med"/>
-                    </a:lnB>
-                    <a:solidFill>
-                      <a:srgbClr val="1A3A5C"/>
-                    </a:solidFill>
-                  </a:tcPr>
-                </a:tc>
-                <a:tc>
-                  <a:txBody>
-                    <a:bodyPr/>
-                    <a:lstStyle/>
-                    <a:p>
-                      <a:pPr marL="0" indent="0" algn="ctr">
-                        <a:buNone/>
-                      </a:pPr>
-                      <a:r>
-                        <a:rPr lang="en-US" sz="2000" b="1" dirty="0">
-                          <a:solidFill>
-                            <a:srgbClr val="FFFFFF"/>
-                          </a:solidFill>
-                          <a:latin typeface="Calibri" pitchFamily="34" charset="0"/>
-                          <a:ea typeface="Calibri" pitchFamily="34" charset="-122"/>
-                          <a:cs typeface="Calibri" pitchFamily="34" charset="-120"/>
-                        </a:rPr>
-                        <a:t>Sig.</a:t>
-                      </a:r>
-                      <a:endParaRPr lang="en-US" sz="2000" dirty="0">
-                        <a:latin typeface="Calibri" charset="0"/>
-                        <a:ea typeface="Calibri" charset="0"/>
-                        <a:cs typeface="Calibri" charset="0"/>
-                      </a:endParaRPr>
-                    </a:p>
-                  </a:txBody>
-                  <a:tcPr>
-                    <a:lnL w="12700" cap="flat" cmpd="sng" algn="ctr">
-                      <a:solidFill>
-                        <a:srgbClr val="C8D6E5"/>
-                      </a:solidFill>
-                      <a:prstDash val="solid"/>
-                      <a:round/>
-                      <a:headEnd type="none" w="med" len="med"/>
-                      <a:tailEnd type="none" w="med" len="med"/>
-                    </a:lnL>
-                    <a:lnR w="12700" cap="flat" cmpd="sng" algn="ctr">
-                      <a:solidFill>
-                        <a:srgbClr val="C8D6E5"/>
-                      </a:solidFill>
-                      <a:prstDash val="solid"/>
-                      <a:round/>
-                      <a:headEnd type="none" w="med" len="med"/>
-                      <a:tailEnd type="none" w="med" len="med"/>
-                    </a:lnR>
-                    <a:lnT w="12700" cap="flat" cmpd="sng" algn="ctr">
-                      <a:solidFill>
-                        <a:srgbClr val="C8D6E5"/>
-                      </a:solidFill>
-                      <a:prstDash val="solid"/>
-                      <a:round/>
-                      <a:headEnd type="none" w="med" len="med"/>
-                      <a:tailEnd type="none" w="med" len="med"/>
-                    </a:lnT>
-                    <a:lnB w="12700" cap="flat" cmpd="sng" algn="ctr">
-                      <a:solidFill>
-                        <a:srgbClr val="C8D6E5"/>
-                      </a:solidFill>
-                      <a:prstDash val="solid"/>
-                      <a:round/>
-                      <a:headEnd type="none" w="med" len="med"/>
-                      <a:tailEnd type="none" w="med" len="med"/>
-                    </a:lnB>
-                    <a:solidFill>
-                      <a:srgbClr val="1A3A5C"/>
-                    </a:solidFill>
-                  </a:tcPr>
-                </a:tc>
-                <a:extLst>
-                  <a:ext uri="{0D108BD9-81ED-4DB2-BD59-A6C34878D82A}">
-                    <a16:rowId xmlns:a16="http://schemas.microsoft.com/office/drawing/2014/main" val="10000"/>
-                  </a:ext>
-                </a:extLst>
-              </a:tr>
-              <a:tr h="621792">
-                <a:tc>
-                  <a:txBody>
-                    <a:bodyPr/>
-                    <a:lstStyle/>
-                    <a:p>
-                      <a:pPr marL="0" indent="0">
-                        <a:buNone/>
-                      </a:pPr>
-                      <a:r>
-                        <a:rPr lang="en-US" sz="2000" dirty="0">
-                          <a:solidFill>
-                            <a:srgbClr val="1C1C1C"/>
-                          </a:solidFill>
-                          <a:latin typeface="Calibri" pitchFamily="34" charset="0"/>
-                          <a:ea typeface="Calibri" pitchFamily="34" charset="-122"/>
-                          <a:cs typeface="Calibri" pitchFamily="34" charset="-120"/>
-                        </a:rPr>
-                        <a:t>Pocket Passer vs. Game Manager</a:t>
-                      </a:r>
-                      <a:endParaRPr lang="en-US" sz="2000" dirty="0">
-                        <a:latin typeface="Calibri" charset="0"/>
-                        <a:ea typeface="Calibri" charset="0"/>
-                        <a:cs typeface="Calibri" charset="0"/>
-                      </a:endParaRPr>
-                    </a:p>
-                  </a:txBody>
-                  <a:tcPr>
-                    <a:lnL w="12700" cap="flat" cmpd="sng" algn="ctr">
-                      <a:solidFill>
-                        <a:srgbClr val="C8D6E5"/>
-                      </a:solidFill>
-                      <a:prstDash val="solid"/>
-                      <a:round/>
-                      <a:headEnd type="none" w="med" len="med"/>
-                      <a:tailEnd type="none" w="med" len="med"/>
-                    </a:lnL>
-                    <a:lnR w="12700" cap="flat" cmpd="sng" algn="ctr">
-                      <a:solidFill>
-                        <a:srgbClr val="C8D6E5"/>
-                      </a:solidFill>
-                      <a:prstDash val="solid"/>
-                      <a:round/>
-                      <a:headEnd type="none" w="med" len="med"/>
-                      <a:tailEnd type="none" w="med" len="med"/>
-                    </a:lnR>
-                    <a:lnT w="12700" cap="flat" cmpd="sng" algn="ctr">
-                      <a:solidFill>
-                        <a:srgbClr val="C8D6E5"/>
-                      </a:solidFill>
-                      <a:prstDash val="solid"/>
-                      <a:round/>
-                      <a:headEnd type="none" w="med" len="med"/>
-                      <a:tailEnd type="none" w="med" len="med"/>
-                    </a:lnT>
-                    <a:lnB w="12700" cap="flat" cmpd="sng" algn="ctr">
-                      <a:solidFill>
-                        <a:srgbClr val="C8D6E5"/>
-                      </a:solidFill>
-                      <a:prstDash val="solid"/>
-                      <a:round/>
-                      <a:headEnd type="none" w="med" len="med"/>
-                      <a:tailEnd type="none" w="med" len="med"/>
-                    </a:lnB>
-                    <a:solidFill>
-                      <a:srgbClr val="F5F9FF"/>
-                    </a:solidFill>
-                  </a:tcPr>
-                </a:tc>
-                <a:tc>
-                  <a:txBody>
-                    <a:bodyPr/>
-                    <a:lstStyle/>
-                    <a:p>
-                      <a:pPr marL="0" indent="0" algn="ctr">
-                        <a:buNone/>
-                      </a:pPr>
-                      <a:r>
-                        <a:rPr lang="en-US" sz="2000" dirty="0">
-                          <a:solidFill>
-                            <a:srgbClr val="B71C1C"/>
-                          </a:solidFill>
-                          <a:latin typeface="Calibri" pitchFamily="34" charset="0"/>
-                          <a:ea typeface="Calibri" pitchFamily="34" charset="-122"/>
-                          <a:cs typeface="Calibri" pitchFamily="34" charset="-120"/>
-                        </a:rPr>
-                        <a:t>&lt; 0.001</a:t>
-                      </a:r>
-                      <a:endParaRPr lang="en-US" sz="2000" dirty="0">
-                        <a:latin typeface="Calibri" charset="0"/>
-                        <a:ea typeface="Calibri" charset="0"/>
-                        <a:cs typeface="Calibri" charset="0"/>
-                      </a:endParaRPr>
-                    </a:p>
-                  </a:txBody>
-                  <a:tcPr>
-                    <a:lnL w="12700" cap="flat" cmpd="sng" algn="ctr">
-                      <a:solidFill>
-                        <a:srgbClr val="C8D6E5"/>
-                      </a:solidFill>
-                      <a:prstDash val="solid"/>
-                      <a:round/>
-                      <a:headEnd type="none" w="med" len="med"/>
-                      <a:tailEnd type="none" w="med" len="med"/>
-                    </a:lnL>
-                    <a:lnR w="12700" cap="flat" cmpd="sng" algn="ctr">
-                      <a:solidFill>
-                        <a:srgbClr val="C8D6E5"/>
-                      </a:solidFill>
-                      <a:prstDash val="solid"/>
-                      <a:round/>
-                      <a:headEnd type="none" w="med" len="med"/>
-                      <a:tailEnd type="none" w="med" len="med"/>
-                    </a:lnR>
-                    <a:lnT w="12700" cap="flat" cmpd="sng" algn="ctr">
-                      <a:solidFill>
-                        <a:srgbClr val="C8D6E5"/>
-                      </a:solidFill>
-                      <a:prstDash val="solid"/>
-                      <a:round/>
-                      <a:headEnd type="none" w="med" len="med"/>
-                      <a:tailEnd type="none" w="med" len="med"/>
-                    </a:lnT>
-                    <a:lnB w="12700" cap="flat" cmpd="sng" algn="ctr">
-                      <a:solidFill>
-                        <a:srgbClr val="C8D6E5"/>
-                      </a:solidFill>
-                      <a:prstDash val="solid"/>
-                      <a:round/>
-                      <a:headEnd type="none" w="med" len="med"/>
-                      <a:tailEnd type="none" w="med" len="med"/>
-                    </a:lnB>
-                    <a:solidFill>
-                      <a:srgbClr val="F5F9FF"/>
-                    </a:solidFill>
-                  </a:tcPr>
-                </a:tc>
-                <a:tc>
-                  <a:txBody>
-                    <a:bodyPr/>
-                    <a:lstStyle/>
-                    <a:p>
-                      <a:pPr marL="0" indent="0" algn="ctr">
-                        <a:buNone/>
-                      </a:pPr>
-                      <a:r>
-                        <a:rPr lang="en-US" sz="2000" b="1" dirty="0">
-                          <a:solidFill>
-                            <a:srgbClr val="B71C1C"/>
-                          </a:solidFill>
-                          <a:latin typeface="Calibri" pitchFamily="34" charset="0"/>
-                          <a:ea typeface="Calibri" pitchFamily="34" charset="-122"/>
-                          <a:cs typeface="Calibri" pitchFamily="34" charset="-120"/>
-                        </a:rPr>
-                        <a:t>***</a:t>
-                      </a:r>
-                      <a:endParaRPr lang="en-US" sz="2000" dirty="0">
-                        <a:latin typeface="Calibri" charset="0"/>
-                        <a:ea typeface="Calibri" charset="0"/>
-                        <a:cs typeface="Calibri" charset="0"/>
-                      </a:endParaRPr>
-                    </a:p>
-                  </a:txBody>
-                  <a:tcPr>
-                    <a:lnL w="12700" cap="flat" cmpd="sng" algn="ctr">
-                      <a:solidFill>
-                        <a:srgbClr val="C8D6E5"/>
-                      </a:solidFill>
-                      <a:prstDash val="solid"/>
-                      <a:round/>
-                      <a:headEnd type="none" w="med" len="med"/>
-                      <a:tailEnd type="none" w="med" len="med"/>
-                    </a:lnL>
-                    <a:lnR w="12700" cap="flat" cmpd="sng" algn="ctr">
-                      <a:solidFill>
-                        <a:srgbClr val="C8D6E5"/>
-                      </a:solidFill>
-                      <a:prstDash val="solid"/>
-                      <a:round/>
-                      <a:headEnd type="none" w="med" len="med"/>
-                      <a:tailEnd type="none" w="med" len="med"/>
-                    </a:lnR>
-                    <a:lnT w="12700" cap="flat" cmpd="sng" algn="ctr">
-                      <a:solidFill>
-                        <a:srgbClr val="C8D6E5"/>
-                      </a:solidFill>
-                      <a:prstDash val="solid"/>
-                      <a:round/>
-                      <a:headEnd type="none" w="med" len="med"/>
-                      <a:tailEnd type="none" w="med" len="med"/>
-                    </a:lnT>
-                    <a:lnB w="12700" cap="flat" cmpd="sng" algn="ctr">
-                      <a:solidFill>
-                        <a:srgbClr val="C8D6E5"/>
-                      </a:solidFill>
-                      <a:prstDash val="solid"/>
-                      <a:round/>
-                      <a:headEnd type="none" w="med" len="med"/>
-                      <a:tailEnd type="none" w="med" len="med"/>
-                    </a:lnB>
-                    <a:solidFill>
-                      <a:srgbClr val="F5F9FF"/>
-                    </a:solidFill>
-                  </a:tcPr>
-                </a:tc>
-                <a:extLst>
-                  <a:ext uri="{0D108BD9-81ED-4DB2-BD59-A6C34878D82A}">
-                    <a16:rowId xmlns:a16="http://schemas.microsoft.com/office/drawing/2014/main" val="10001"/>
-                  </a:ext>
-                </a:extLst>
-              </a:tr>
-              <a:tr h="621792">
-                <a:tc>
-                  <a:txBody>
-                    <a:bodyPr/>
-                    <a:lstStyle/>
-                    <a:p>
-                      <a:pPr marL="0" indent="0">
-                        <a:buNone/>
-                      </a:pPr>
-                      <a:r>
-                        <a:rPr lang="en-US" sz="2000" dirty="0">
-                          <a:solidFill>
-                            <a:srgbClr val="1C1C1C"/>
-                          </a:solidFill>
-                          <a:latin typeface="Calibri" pitchFamily="34" charset="0"/>
-                          <a:ea typeface="Calibri" pitchFamily="34" charset="-122"/>
-                          <a:cs typeface="Calibri" pitchFamily="34" charset="-120"/>
-                        </a:rPr>
-                        <a:t>Pocket Passer vs. Gunslinger</a:t>
-                      </a:r>
-                      <a:endParaRPr lang="en-US" sz="2000" dirty="0">
-                        <a:latin typeface="Calibri" charset="0"/>
-                        <a:ea typeface="Calibri" charset="0"/>
-                        <a:cs typeface="Calibri" charset="0"/>
-                      </a:endParaRPr>
-                    </a:p>
-                  </a:txBody>
-                  <a:tcPr>
-                    <a:lnL w="12700" cap="flat" cmpd="sng" algn="ctr">
-                      <a:solidFill>
-                        <a:srgbClr val="C8D6E5"/>
-                      </a:solidFill>
-                      <a:prstDash val="solid"/>
-                      <a:round/>
-                      <a:headEnd type="none" w="med" len="med"/>
-                      <a:tailEnd type="none" w="med" len="med"/>
-                    </a:lnL>
-                    <a:lnR w="12700" cap="flat" cmpd="sng" algn="ctr">
-                      <a:solidFill>
-                        <a:srgbClr val="C8D6E5"/>
-                      </a:solidFill>
-                      <a:prstDash val="solid"/>
-                      <a:round/>
-                      <a:headEnd type="none" w="med" len="med"/>
-                      <a:tailEnd type="none" w="med" len="med"/>
-                    </a:lnR>
-                    <a:lnT w="12700" cap="flat" cmpd="sng" algn="ctr">
-                      <a:solidFill>
-                        <a:srgbClr val="C8D6E5"/>
-                      </a:solidFill>
-                      <a:prstDash val="solid"/>
-                      <a:round/>
-                      <a:headEnd type="none" w="med" len="med"/>
-                      <a:tailEnd type="none" w="med" len="med"/>
-                    </a:lnT>
-                    <a:lnB w="12700" cap="flat" cmpd="sng" algn="ctr">
-                      <a:solidFill>
-                        <a:srgbClr val="C8D6E5"/>
-                      </a:solidFill>
-                      <a:prstDash val="solid"/>
-                      <a:round/>
-                      <a:headEnd type="none" w="med" len="med"/>
-                      <a:tailEnd type="none" w="med" len="med"/>
-                    </a:lnB>
-                    <a:solidFill>
-                      <a:srgbClr val="FFFFFF"/>
-                    </a:solidFill>
-                  </a:tcPr>
-                </a:tc>
-                <a:tc>
-                  <a:txBody>
-                    <a:bodyPr/>
-                    <a:lstStyle/>
-                    <a:p>
-                      <a:pPr marL="0" indent="0" algn="ctr">
-                        <a:buNone/>
-                      </a:pPr>
-                      <a:r>
-                        <a:rPr lang="en-US" sz="2000" dirty="0">
-                          <a:solidFill>
-                            <a:srgbClr val="B71C1C"/>
-                          </a:solidFill>
-                          <a:latin typeface="Calibri" pitchFamily="34" charset="0"/>
-                          <a:ea typeface="Calibri" pitchFamily="34" charset="-122"/>
-                          <a:cs typeface="Calibri" pitchFamily="34" charset="-120"/>
-                        </a:rPr>
-                        <a:t>&lt; 0.001</a:t>
-                      </a:r>
-                      <a:endParaRPr lang="en-US" sz="2000" dirty="0">
-                        <a:latin typeface="Calibri" charset="0"/>
-                        <a:ea typeface="Calibri" charset="0"/>
-                        <a:cs typeface="Calibri" charset="0"/>
-                      </a:endParaRPr>
-                    </a:p>
-                  </a:txBody>
-                  <a:tcPr>
-                    <a:lnL w="12700" cap="flat" cmpd="sng" algn="ctr">
-                      <a:solidFill>
-                        <a:srgbClr val="C8D6E5"/>
-                      </a:solidFill>
-                      <a:prstDash val="solid"/>
-                      <a:round/>
-                      <a:headEnd type="none" w="med" len="med"/>
-                      <a:tailEnd type="none" w="med" len="med"/>
-                    </a:lnL>
-                    <a:lnR w="12700" cap="flat" cmpd="sng" algn="ctr">
-                      <a:solidFill>
-                        <a:srgbClr val="C8D6E5"/>
-                      </a:solidFill>
-                      <a:prstDash val="solid"/>
-                      <a:round/>
-                      <a:headEnd type="none" w="med" len="med"/>
-                      <a:tailEnd type="none" w="med" len="med"/>
-                    </a:lnR>
-                    <a:lnT w="12700" cap="flat" cmpd="sng" algn="ctr">
-                      <a:solidFill>
-                        <a:srgbClr val="C8D6E5"/>
-                      </a:solidFill>
-                      <a:prstDash val="solid"/>
-                      <a:round/>
-                      <a:headEnd type="none" w="med" len="med"/>
-                      <a:tailEnd type="none" w="med" len="med"/>
-                    </a:lnT>
-                    <a:lnB w="12700" cap="flat" cmpd="sng" algn="ctr">
-                      <a:solidFill>
-                        <a:srgbClr val="C8D6E5"/>
-                      </a:solidFill>
-                      <a:prstDash val="solid"/>
-                      <a:round/>
-                      <a:headEnd type="none" w="med" len="med"/>
-                      <a:tailEnd type="none" w="med" len="med"/>
-                    </a:lnB>
-                    <a:solidFill>
-                      <a:srgbClr val="FFFFFF"/>
-                    </a:solidFill>
-                  </a:tcPr>
-                </a:tc>
-                <a:tc>
-                  <a:txBody>
-                    <a:bodyPr/>
-                    <a:lstStyle/>
-                    <a:p>
-                      <a:pPr marL="0" indent="0" algn="ctr">
-                        <a:buNone/>
-                      </a:pPr>
-                      <a:r>
-                        <a:rPr lang="en-US" sz="2000" b="1" dirty="0">
-                          <a:solidFill>
-                            <a:srgbClr val="B71C1C"/>
-                          </a:solidFill>
-                          <a:latin typeface="Calibri" pitchFamily="34" charset="0"/>
-                          <a:ea typeface="Calibri" pitchFamily="34" charset="-122"/>
-                          <a:cs typeface="Calibri" pitchFamily="34" charset="-120"/>
-                        </a:rPr>
-                        <a:t>***</a:t>
-                      </a:r>
-                      <a:endParaRPr lang="en-US" sz="2000" dirty="0">
-                        <a:latin typeface="Calibri" charset="0"/>
-                        <a:ea typeface="Calibri" charset="0"/>
-                        <a:cs typeface="Calibri" charset="0"/>
-                      </a:endParaRPr>
-                    </a:p>
-                  </a:txBody>
-                  <a:tcPr>
-                    <a:lnL w="12700" cap="flat" cmpd="sng" algn="ctr">
-                      <a:solidFill>
-                        <a:srgbClr val="C8D6E5"/>
-                      </a:solidFill>
-                      <a:prstDash val="solid"/>
-                      <a:round/>
-                      <a:headEnd type="none" w="med" len="med"/>
-                      <a:tailEnd type="none" w="med" len="med"/>
-                    </a:lnL>
-                    <a:lnR w="12700" cap="flat" cmpd="sng" algn="ctr">
-                      <a:solidFill>
-                        <a:srgbClr val="C8D6E5"/>
-                      </a:solidFill>
-                      <a:prstDash val="solid"/>
-                      <a:round/>
-                      <a:headEnd type="none" w="med" len="med"/>
-                      <a:tailEnd type="none" w="med" len="med"/>
-                    </a:lnR>
-                    <a:lnT w="12700" cap="flat" cmpd="sng" algn="ctr">
-                      <a:solidFill>
-                        <a:srgbClr val="C8D6E5"/>
-                      </a:solidFill>
-                      <a:prstDash val="solid"/>
-                      <a:round/>
-                      <a:headEnd type="none" w="med" len="med"/>
-                      <a:tailEnd type="none" w="med" len="med"/>
-                    </a:lnT>
-                    <a:lnB w="12700" cap="flat" cmpd="sng" algn="ctr">
-                      <a:solidFill>
-                        <a:srgbClr val="C8D6E5"/>
-                      </a:solidFill>
-                      <a:prstDash val="solid"/>
-                      <a:round/>
-                      <a:headEnd type="none" w="med" len="med"/>
-                      <a:tailEnd type="none" w="med" len="med"/>
-                    </a:lnB>
-                    <a:solidFill>
-                      <a:srgbClr val="FFFFFF"/>
-                    </a:solidFill>
-                  </a:tcPr>
-                </a:tc>
-                <a:extLst>
-                  <a:ext uri="{0D108BD9-81ED-4DB2-BD59-A6C34878D82A}">
-                    <a16:rowId xmlns:a16="http://schemas.microsoft.com/office/drawing/2014/main" val="10002"/>
-                  </a:ext>
-                </a:extLst>
-              </a:tr>
-              <a:tr h="621792">
-                <a:tc>
-                  <a:txBody>
-                    <a:bodyPr/>
-                    <a:lstStyle/>
-                    <a:p>
-                      <a:pPr marL="0" indent="0">
-                        <a:buNone/>
-                      </a:pPr>
-                      <a:r>
-                        <a:rPr lang="en-US" sz="2000" dirty="0">
-                          <a:solidFill>
-                            <a:srgbClr val="1C1C1C"/>
-                          </a:solidFill>
-                          <a:latin typeface="Calibri" pitchFamily="34" charset="0"/>
-                          <a:ea typeface="Calibri" pitchFamily="34" charset="-122"/>
-                          <a:cs typeface="Calibri" pitchFamily="34" charset="-120"/>
-                        </a:rPr>
-                        <a:t>Pocket Passer vs. Dual Threat</a:t>
-                      </a:r>
-                      <a:endParaRPr lang="en-US" sz="2000" dirty="0">
-                        <a:latin typeface="Calibri" charset="0"/>
-                        <a:ea typeface="Calibri" charset="0"/>
-                        <a:cs typeface="Calibri" charset="0"/>
-                      </a:endParaRPr>
-                    </a:p>
-                  </a:txBody>
-                  <a:tcPr>
-                    <a:lnL w="12700" cap="flat" cmpd="sng" algn="ctr">
-                      <a:solidFill>
-                        <a:srgbClr val="C8D6E5"/>
-                      </a:solidFill>
-                      <a:prstDash val="solid"/>
-                      <a:round/>
-                      <a:headEnd type="none" w="med" len="med"/>
-                      <a:tailEnd type="none" w="med" len="med"/>
-                    </a:lnL>
-                    <a:lnR w="12700" cap="flat" cmpd="sng" algn="ctr">
-                      <a:solidFill>
-                        <a:srgbClr val="C8D6E5"/>
-                      </a:solidFill>
-                      <a:prstDash val="solid"/>
-                      <a:round/>
-                      <a:headEnd type="none" w="med" len="med"/>
-                      <a:tailEnd type="none" w="med" len="med"/>
-                    </a:lnR>
-                    <a:lnT w="12700" cap="flat" cmpd="sng" algn="ctr">
-                      <a:solidFill>
-                        <a:srgbClr val="C8D6E5"/>
-                      </a:solidFill>
-                      <a:prstDash val="solid"/>
-                      <a:round/>
-                      <a:headEnd type="none" w="med" len="med"/>
-                      <a:tailEnd type="none" w="med" len="med"/>
-                    </a:lnT>
-                    <a:lnB w="12700" cap="flat" cmpd="sng" algn="ctr">
-                      <a:solidFill>
-                        <a:srgbClr val="C8D6E5"/>
-                      </a:solidFill>
-                      <a:prstDash val="solid"/>
-                      <a:round/>
-                      <a:headEnd type="none" w="med" len="med"/>
-                      <a:tailEnd type="none" w="med" len="med"/>
-                    </a:lnB>
-                    <a:solidFill>
-                      <a:srgbClr val="F5F9FF"/>
-                    </a:solidFill>
-                  </a:tcPr>
-                </a:tc>
-                <a:tc>
-                  <a:txBody>
-                    <a:bodyPr/>
-                    <a:lstStyle/>
-                    <a:p>
-                      <a:pPr marL="0" indent="0" algn="ctr">
-                        <a:buNone/>
-                      </a:pPr>
-                      <a:r>
-                        <a:rPr lang="en-US" sz="2000" dirty="0">
-                          <a:solidFill>
-                            <a:srgbClr val="5A6A7A"/>
-                          </a:solidFill>
-                          <a:latin typeface="Calibri" pitchFamily="34" charset="0"/>
-                          <a:ea typeface="Calibri" pitchFamily="34" charset="-122"/>
-                          <a:cs typeface="Calibri" pitchFamily="34" charset="-120"/>
-                        </a:rPr>
-                        <a:t>0.9439</a:t>
-                      </a:r>
-                      <a:endParaRPr lang="en-US" sz="2000" dirty="0">
-                        <a:latin typeface="Calibri" charset="0"/>
-                        <a:ea typeface="Calibri" charset="0"/>
-                        <a:cs typeface="Calibri" charset="0"/>
-                      </a:endParaRPr>
-                    </a:p>
-                  </a:txBody>
-                  <a:tcPr>
-                    <a:lnL w="12700" cap="flat" cmpd="sng" algn="ctr">
-                      <a:solidFill>
-                        <a:srgbClr val="C8D6E5"/>
-                      </a:solidFill>
-                      <a:prstDash val="solid"/>
-                      <a:round/>
-                      <a:headEnd type="none" w="med" len="med"/>
-                      <a:tailEnd type="none" w="med" len="med"/>
-                    </a:lnL>
-                    <a:lnR w="12700" cap="flat" cmpd="sng" algn="ctr">
-                      <a:solidFill>
-                        <a:srgbClr val="C8D6E5"/>
-                      </a:solidFill>
-                      <a:prstDash val="solid"/>
-                      <a:round/>
-                      <a:headEnd type="none" w="med" len="med"/>
-                      <a:tailEnd type="none" w="med" len="med"/>
-                    </a:lnR>
-                    <a:lnT w="12700" cap="flat" cmpd="sng" algn="ctr">
-                      <a:solidFill>
-                        <a:srgbClr val="C8D6E5"/>
-                      </a:solidFill>
-                      <a:prstDash val="solid"/>
-                      <a:round/>
-                      <a:headEnd type="none" w="med" len="med"/>
-                      <a:tailEnd type="none" w="med" len="med"/>
-                    </a:lnT>
-                    <a:lnB w="12700" cap="flat" cmpd="sng" algn="ctr">
-                      <a:solidFill>
-                        <a:srgbClr val="C8D6E5"/>
-                      </a:solidFill>
-                      <a:prstDash val="solid"/>
-                      <a:round/>
-                      <a:headEnd type="none" w="med" len="med"/>
-                      <a:tailEnd type="none" w="med" len="med"/>
-                    </a:lnB>
-                    <a:solidFill>
-                      <a:srgbClr val="F5F9FF"/>
-                    </a:solidFill>
-                  </a:tcPr>
-                </a:tc>
-                <a:tc>
-                  <a:txBody>
-                    <a:bodyPr/>
-                    <a:lstStyle/>
-                    <a:p>
-                      <a:pPr marL="0" indent="0" algn="ctr">
-                        <a:buNone/>
-                      </a:pPr>
-                      <a:r>
-                        <a:rPr lang="en-US" sz="2000" dirty="0">
-                          <a:solidFill>
-                            <a:srgbClr val="5A6A7A"/>
-                          </a:solidFill>
-                          <a:latin typeface="Calibri" pitchFamily="34" charset="0"/>
-                          <a:ea typeface="Calibri" pitchFamily="34" charset="-122"/>
-                          <a:cs typeface="Calibri" pitchFamily="34" charset="-120"/>
-                        </a:rPr>
-                        <a:t>ns</a:t>
-                      </a:r>
-                      <a:endParaRPr lang="en-US" sz="2000" dirty="0">
-                        <a:latin typeface="Calibri" charset="0"/>
-                        <a:ea typeface="Calibri" charset="0"/>
-                        <a:cs typeface="Calibri" charset="0"/>
-                      </a:endParaRPr>
-                    </a:p>
-                  </a:txBody>
-                  <a:tcPr>
-                    <a:lnL w="12700" cap="flat" cmpd="sng" algn="ctr">
-                      <a:solidFill>
-                        <a:srgbClr val="C8D6E5"/>
-                      </a:solidFill>
-                      <a:prstDash val="solid"/>
-                      <a:round/>
-                      <a:headEnd type="none" w="med" len="med"/>
-                      <a:tailEnd type="none" w="med" len="med"/>
-                    </a:lnL>
-                    <a:lnR w="12700" cap="flat" cmpd="sng" algn="ctr">
-                      <a:solidFill>
-                        <a:srgbClr val="C8D6E5"/>
-                      </a:solidFill>
-                      <a:prstDash val="solid"/>
-                      <a:round/>
-                      <a:headEnd type="none" w="med" len="med"/>
-                      <a:tailEnd type="none" w="med" len="med"/>
-                    </a:lnR>
-                    <a:lnT w="12700" cap="flat" cmpd="sng" algn="ctr">
-                      <a:solidFill>
-                        <a:srgbClr val="C8D6E5"/>
-                      </a:solidFill>
-                      <a:prstDash val="solid"/>
-                      <a:round/>
-                      <a:headEnd type="none" w="med" len="med"/>
-                      <a:tailEnd type="none" w="med" len="med"/>
-                    </a:lnT>
-                    <a:lnB w="12700" cap="flat" cmpd="sng" algn="ctr">
-                      <a:solidFill>
-                        <a:srgbClr val="C8D6E5"/>
-                      </a:solidFill>
-                      <a:prstDash val="solid"/>
-                      <a:round/>
-                      <a:headEnd type="none" w="med" len="med"/>
-                      <a:tailEnd type="none" w="med" len="med"/>
-                    </a:lnB>
-                    <a:solidFill>
-                      <a:srgbClr val="F5F9FF"/>
-                    </a:solidFill>
-                  </a:tcPr>
-                </a:tc>
-                <a:extLst>
-                  <a:ext uri="{0D108BD9-81ED-4DB2-BD59-A6C34878D82A}">
-                    <a16:rowId xmlns:a16="http://schemas.microsoft.com/office/drawing/2014/main" val="10003"/>
-                  </a:ext>
-                </a:extLst>
-              </a:tr>
-              <a:tr h="621792">
-                <a:tc>
-                  <a:txBody>
-                    <a:bodyPr/>
-                    <a:lstStyle/>
-                    <a:p>
-                      <a:pPr marL="0" indent="0">
-                        <a:buNone/>
-                      </a:pPr>
-                      <a:r>
-                        <a:rPr lang="en-US" sz="2000" dirty="0">
-                          <a:solidFill>
-                            <a:srgbClr val="1C1C1C"/>
-                          </a:solidFill>
-                          <a:latin typeface="Calibri" pitchFamily="34" charset="0"/>
-                          <a:ea typeface="Calibri" pitchFamily="34" charset="-122"/>
-                          <a:cs typeface="Calibri" pitchFamily="34" charset="-120"/>
-                        </a:rPr>
-                        <a:t>Game Manager vs. Dual Threat</a:t>
-                      </a:r>
-                      <a:endParaRPr lang="en-US" sz="2000" dirty="0">
-                        <a:latin typeface="Calibri" charset="0"/>
-                        <a:ea typeface="Calibri" charset="0"/>
-                        <a:cs typeface="Calibri" charset="0"/>
-                      </a:endParaRPr>
-                    </a:p>
-                  </a:txBody>
-                  <a:tcPr>
-                    <a:lnL w="12700" cap="flat" cmpd="sng" algn="ctr">
-                      <a:solidFill>
-                        <a:srgbClr val="C8D6E5"/>
-                      </a:solidFill>
-                      <a:prstDash val="solid"/>
-                      <a:round/>
-                      <a:headEnd type="none" w="med" len="med"/>
-                      <a:tailEnd type="none" w="med" len="med"/>
-                    </a:lnL>
-                    <a:lnR w="12700" cap="flat" cmpd="sng" algn="ctr">
-                      <a:solidFill>
-                        <a:srgbClr val="C8D6E5"/>
-                      </a:solidFill>
-                      <a:prstDash val="solid"/>
-                      <a:round/>
-                      <a:headEnd type="none" w="med" len="med"/>
-                      <a:tailEnd type="none" w="med" len="med"/>
-                    </a:lnR>
-                    <a:lnT w="12700" cap="flat" cmpd="sng" algn="ctr">
-                      <a:solidFill>
-                        <a:srgbClr val="C8D6E5"/>
-                      </a:solidFill>
-                      <a:prstDash val="solid"/>
-                      <a:round/>
-                      <a:headEnd type="none" w="med" len="med"/>
-                      <a:tailEnd type="none" w="med" len="med"/>
-                    </a:lnT>
-                    <a:lnB w="12700" cap="flat" cmpd="sng" algn="ctr">
-                      <a:solidFill>
-                        <a:srgbClr val="C8D6E5"/>
-                      </a:solidFill>
-                      <a:prstDash val="solid"/>
-                      <a:round/>
-                      <a:headEnd type="none" w="med" len="med"/>
-                      <a:tailEnd type="none" w="med" len="med"/>
-                    </a:lnB>
-                    <a:solidFill>
-                      <a:srgbClr val="FFFFFF"/>
-                    </a:solidFill>
-                  </a:tcPr>
-                </a:tc>
-                <a:tc>
-                  <a:txBody>
-                    <a:bodyPr/>
-                    <a:lstStyle/>
-                    <a:p>
-                      <a:pPr marL="0" indent="0" algn="ctr">
-                        <a:buNone/>
-                      </a:pPr>
-                      <a:r>
-                        <a:rPr lang="en-US" sz="2000" dirty="0">
-                          <a:solidFill>
-                            <a:srgbClr val="B71C1C"/>
-                          </a:solidFill>
-                          <a:latin typeface="Calibri" pitchFamily="34" charset="0"/>
-                          <a:ea typeface="Calibri" pitchFamily="34" charset="-122"/>
-                          <a:cs typeface="Calibri" pitchFamily="34" charset="-120"/>
-                        </a:rPr>
-                        <a:t>&lt; 0.001</a:t>
-                      </a:r>
-                      <a:endParaRPr lang="en-US" sz="2000" dirty="0">
-                        <a:latin typeface="Calibri" charset="0"/>
-                        <a:ea typeface="Calibri" charset="0"/>
-                        <a:cs typeface="Calibri" charset="0"/>
-                      </a:endParaRPr>
-                    </a:p>
-                  </a:txBody>
-                  <a:tcPr>
-                    <a:lnL w="12700" cap="flat" cmpd="sng" algn="ctr">
-                      <a:solidFill>
-                        <a:srgbClr val="C8D6E5"/>
-                      </a:solidFill>
-                      <a:prstDash val="solid"/>
-                      <a:round/>
-                      <a:headEnd type="none" w="med" len="med"/>
-                      <a:tailEnd type="none" w="med" len="med"/>
-                    </a:lnL>
-                    <a:lnR w="12700" cap="flat" cmpd="sng" algn="ctr">
-                      <a:solidFill>
-                        <a:srgbClr val="C8D6E5"/>
-                      </a:solidFill>
-                      <a:prstDash val="solid"/>
-                      <a:round/>
-                      <a:headEnd type="none" w="med" len="med"/>
-                      <a:tailEnd type="none" w="med" len="med"/>
-                    </a:lnR>
-                    <a:lnT w="12700" cap="flat" cmpd="sng" algn="ctr">
-                      <a:solidFill>
-                        <a:srgbClr val="C8D6E5"/>
-                      </a:solidFill>
-                      <a:prstDash val="solid"/>
-                      <a:round/>
-                      <a:headEnd type="none" w="med" len="med"/>
-                      <a:tailEnd type="none" w="med" len="med"/>
-                    </a:lnT>
-                    <a:lnB w="12700" cap="flat" cmpd="sng" algn="ctr">
-                      <a:solidFill>
-                        <a:srgbClr val="C8D6E5"/>
-                      </a:solidFill>
-                      <a:prstDash val="solid"/>
-                      <a:round/>
-                      <a:headEnd type="none" w="med" len="med"/>
-                      <a:tailEnd type="none" w="med" len="med"/>
-                    </a:lnB>
-                    <a:solidFill>
-                      <a:srgbClr val="FFFFFF"/>
-                    </a:solidFill>
-                  </a:tcPr>
-                </a:tc>
-                <a:tc>
-                  <a:txBody>
-                    <a:bodyPr/>
-                    <a:lstStyle/>
-                    <a:p>
-                      <a:pPr marL="0" indent="0" algn="ctr">
-                        <a:buNone/>
-                      </a:pPr>
-                      <a:r>
-                        <a:rPr lang="en-US" sz="2000" b="1" dirty="0">
-                          <a:solidFill>
-                            <a:srgbClr val="B71C1C"/>
-                          </a:solidFill>
-                          <a:latin typeface="Calibri" pitchFamily="34" charset="0"/>
-                          <a:ea typeface="Calibri" pitchFamily="34" charset="-122"/>
-                          <a:cs typeface="Calibri" pitchFamily="34" charset="-120"/>
-                        </a:rPr>
-                        <a:t>***</a:t>
-                      </a:r>
-                      <a:endParaRPr lang="en-US" sz="2000" dirty="0">
-                        <a:latin typeface="Calibri" charset="0"/>
-                        <a:ea typeface="Calibri" charset="0"/>
-                        <a:cs typeface="Calibri" charset="0"/>
-                      </a:endParaRPr>
-                    </a:p>
-                  </a:txBody>
-                  <a:tcPr>
-                    <a:lnL w="12700" cap="flat" cmpd="sng" algn="ctr">
-                      <a:solidFill>
-                        <a:srgbClr val="C8D6E5"/>
-                      </a:solidFill>
-                      <a:prstDash val="solid"/>
-                      <a:round/>
-                      <a:headEnd type="none" w="med" len="med"/>
-                      <a:tailEnd type="none" w="med" len="med"/>
-                    </a:lnL>
-                    <a:lnR w="12700" cap="flat" cmpd="sng" algn="ctr">
-                      <a:solidFill>
-                        <a:srgbClr val="C8D6E5"/>
-                      </a:solidFill>
-                      <a:prstDash val="solid"/>
-                      <a:round/>
-                      <a:headEnd type="none" w="med" len="med"/>
-                      <a:tailEnd type="none" w="med" len="med"/>
-                    </a:lnR>
-                    <a:lnT w="12700" cap="flat" cmpd="sng" algn="ctr">
-                      <a:solidFill>
-                        <a:srgbClr val="C8D6E5"/>
-                      </a:solidFill>
-                      <a:prstDash val="solid"/>
-                      <a:round/>
-                      <a:headEnd type="none" w="med" len="med"/>
-                      <a:tailEnd type="none" w="med" len="med"/>
-                    </a:lnT>
-                    <a:lnB w="12700" cap="flat" cmpd="sng" algn="ctr">
-                      <a:solidFill>
-                        <a:srgbClr val="C8D6E5"/>
-                      </a:solidFill>
-                      <a:prstDash val="solid"/>
-                      <a:round/>
-                      <a:headEnd type="none" w="med" len="med"/>
-                      <a:tailEnd type="none" w="med" len="med"/>
-                    </a:lnB>
-                    <a:solidFill>
-                      <a:srgbClr val="FFFFFF"/>
-                    </a:solidFill>
-                  </a:tcPr>
-                </a:tc>
-                <a:extLst>
-                  <a:ext uri="{0D108BD9-81ED-4DB2-BD59-A6C34878D82A}">
-                    <a16:rowId xmlns:a16="http://schemas.microsoft.com/office/drawing/2014/main" val="10004"/>
-                  </a:ext>
-                </a:extLst>
-              </a:tr>
-              <a:tr h="621792">
-                <a:tc>
-                  <a:txBody>
-                    <a:bodyPr/>
-                    <a:lstStyle/>
-                    <a:p>
-                      <a:pPr marL="0" indent="0">
-                        <a:buNone/>
-                      </a:pPr>
-                      <a:r>
-                        <a:rPr lang="en-US" sz="2000" dirty="0">
-                          <a:solidFill>
-                            <a:srgbClr val="1C1C1C"/>
-                          </a:solidFill>
-                          <a:latin typeface="Calibri" pitchFamily="34" charset="0"/>
-                          <a:ea typeface="Calibri" pitchFamily="34" charset="-122"/>
-                          <a:cs typeface="Calibri" pitchFamily="34" charset="-120"/>
-                        </a:rPr>
-                        <a:t>Gunslinger vs. Dual Threat</a:t>
-                      </a:r>
-                      <a:endParaRPr lang="en-US" sz="2000" dirty="0">
-                        <a:latin typeface="Calibri" charset="0"/>
-                        <a:ea typeface="Calibri" charset="0"/>
-                        <a:cs typeface="Calibri" charset="0"/>
-                      </a:endParaRPr>
-                    </a:p>
-                  </a:txBody>
-                  <a:tcPr>
-                    <a:lnL w="12700" cap="flat" cmpd="sng" algn="ctr">
-                      <a:solidFill>
-                        <a:srgbClr val="C8D6E5"/>
-                      </a:solidFill>
-                      <a:prstDash val="solid"/>
-                      <a:round/>
-                      <a:headEnd type="none" w="med" len="med"/>
-                      <a:tailEnd type="none" w="med" len="med"/>
-                    </a:lnL>
-                    <a:lnR w="12700" cap="flat" cmpd="sng" algn="ctr">
-                      <a:solidFill>
-                        <a:srgbClr val="C8D6E5"/>
-                      </a:solidFill>
-                      <a:prstDash val="solid"/>
-                      <a:round/>
-                      <a:headEnd type="none" w="med" len="med"/>
-                      <a:tailEnd type="none" w="med" len="med"/>
-                    </a:lnR>
-                    <a:lnT w="12700" cap="flat" cmpd="sng" algn="ctr">
-                      <a:solidFill>
-                        <a:srgbClr val="C8D6E5"/>
-                      </a:solidFill>
-                      <a:prstDash val="solid"/>
-                      <a:round/>
-                      <a:headEnd type="none" w="med" len="med"/>
-                      <a:tailEnd type="none" w="med" len="med"/>
-                    </a:lnT>
-                    <a:lnB w="12700" cap="flat" cmpd="sng" algn="ctr">
-                      <a:solidFill>
-                        <a:srgbClr val="C8D6E5"/>
-                      </a:solidFill>
-                      <a:prstDash val="solid"/>
-                      <a:round/>
-                      <a:headEnd type="none" w="med" len="med"/>
-                      <a:tailEnd type="none" w="med" len="med"/>
-                    </a:lnB>
-                    <a:solidFill>
-                      <a:srgbClr val="F5F9FF"/>
-                    </a:solidFill>
-                  </a:tcPr>
-                </a:tc>
-                <a:tc>
-                  <a:txBody>
-                    <a:bodyPr/>
-                    <a:lstStyle/>
-                    <a:p>
-                      <a:pPr marL="0" indent="0" algn="ctr">
-                        <a:buNone/>
-                      </a:pPr>
-                      <a:r>
-                        <a:rPr lang="en-US" sz="2000" dirty="0">
-                          <a:solidFill>
-                            <a:srgbClr val="B71C1C"/>
-                          </a:solidFill>
-                          <a:latin typeface="Calibri" pitchFamily="34" charset="0"/>
-                          <a:ea typeface="Calibri" pitchFamily="34" charset="-122"/>
-                          <a:cs typeface="Calibri" pitchFamily="34" charset="-120"/>
-                        </a:rPr>
-                        <a:t>&lt; 0.001</a:t>
-                      </a:r>
-                      <a:endParaRPr lang="en-US" sz="2000" dirty="0">
-                        <a:latin typeface="Calibri" charset="0"/>
-                        <a:ea typeface="Calibri" charset="0"/>
-                        <a:cs typeface="Calibri" charset="0"/>
-                      </a:endParaRPr>
-                    </a:p>
-                  </a:txBody>
-                  <a:tcPr>
-                    <a:lnL w="12700" cap="flat" cmpd="sng" algn="ctr">
-                      <a:solidFill>
-                        <a:srgbClr val="C8D6E5"/>
-                      </a:solidFill>
-                      <a:prstDash val="solid"/>
-                      <a:round/>
-                      <a:headEnd type="none" w="med" len="med"/>
-                      <a:tailEnd type="none" w="med" len="med"/>
-                    </a:lnL>
-                    <a:lnR w="12700" cap="flat" cmpd="sng" algn="ctr">
-                      <a:solidFill>
-                        <a:srgbClr val="C8D6E5"/>
-                      </a:solidFill>
-                      <a:prstDash val="solid"/>
-                      <a:round/>
-                      <a:headEnd type="none" w="med" len="med"/>
-                      <a:tailEnd type="none" w="med" len="med"/>
-                    </a:lnR>
-                    <a:lnT w="12700" cap="flat" cmpd="sng" algn="ctr">
-                      <a:solidFill>
-                        <a:srgbClr val="C8D6E5"/>
-                      </a:solidFill>
-                      <a:prstDash val="solid"/>
-                      <a:round/>
-                      <a:headEnd type="none" w="med" len="med"/>
-                      <a:tailEnd type="none" w="med" len="med"/>
-                    </a:lnT>
-                    <a:lnB w="12700" cap="flat" cmpd="sng" algn="ctr">
-                      <a:solidFill>
-                        <a:srgbClr val="C8D6E5"/>
-                      </a:solidFill>
-                      <a:prstDash val="solid"/>
-                      <a:round/>
-                      <a:headEnd type="none" w="med" len="med"/>
-                      <a:tailEnd type="none" w="med" len="med"/>
-                    </a:lnB>
-                    <a:solidFill>
-                      <a:srgbClr val="F5F9FF"/>
-                    </a:solidFill>
-                  </a:tcPr>
-                </a:tc>
-                <a:tc>
-                  <a:txBody>
-                    <a:bodyPr/>
-                    <a:lstStyle/>
-                    <a:p>
-                      <a:pPr marL="0" indent="0" algn="ctr">
-                        <a:buNone/>
-                      </a:pPr>
-                      <a:r>
-                        <a:rPr lang="en-US" sz="2000" b="1" dirty="0">
-                          <a:solidFill>
-                            <a:srgbClr val="B71C1C"/>
-                          </a:solidFill>
-                          <a:latin typeface="Calibri" pitchFamily="34" charset="0"/>
-                          <a:ea typeface="Calibri" pitchFamily="34" charset="-122"/>
-                          <a:cs typeface="Calibri" pitchFamily="34" charset="-120"/>
-                        </a:rPr>
-                        <a:t>***</a:t>
-                      </a:r>
-                      <a:endParaRPr lang="en-US" sz="2000" dirty="0">
-                        <a:latin typeface="Calibri" charset="0"/>
-                        <a:ea typeface="Calibri" charset="0"/>
-                        <a:cs typeface="Calibri" charset="0"/>
-                      </a:endParaRPr>
-                    </a:p>
-                  </a:txBody>
-                  <a:tcPr>
-                    <a:lnL w="12700" cap="flat" cmpd="sng" algn="ctr">
-                      <a:solidFill>
-                        <a:srgbClr val="C8D6E5"/>
-                      </a:solidFill>
-                      <a:prstDash val="solid"/>
-                      <a:round/>
-                      <a:headEnd type="none" w="med" len="med"/>
-                      <a:tailEnd type="none" w="med" len="med"/>
-                    </a:lnL>
-                    <a:lnR w="12700" cap="flat" cmpd="sng" algn="ctr">
-                      <a:solidFill>
-                        <a:srgbClr val="C8D6E5"/>
-                      </a:solidFill>
-                      <a:prstDash val="solid"/>
-                      <a:round/>
-                      <a:headEnd type="none" w="med" len="med"/>
-                      <a:tailEnd type="none" w="med" len="med"/>
-                    </a:lnR>
-                    <a:lnT w="12700" cap="flat" cmpd="sng" algn="ctr">
-                      <a:solidFill>
-                        <a:srgbClr val="C8D6E5"/>
-                      </a:solidFill>
-                      <a:prstDash val="solid"/>
-                      <a:round/>
-                      <a:headEnd type="none" w="med" len="med"/>
-                      <a:tailEnd type="none" w="med" len="med"/>
-                    </a:lnT>
-                    <a:lnB w="12700" cap="flat" cmpd="sng" algn="ctr">
-                      <a:solidFill>
-                        <a:srgbClr val="C8D6E5"/>
-                      </a:solidFill>
-                      <a:prstDash val="solid"/>
-                      <a:round/>
-                      <a:headEnd type="none" w="med" len="med"/>
-                      <a:tailEnd type="none" w="med" len="med"/>
-                    </a:lnB>
-                    <a:solidFill>
-                      <a:srgbClr val="F5F9FF"/>
-                    </a:solidFill>
-                  </a:tcPr>
-                </a:tc>
-                <a:extLst>
-                  <a:ext uri="{0D108BD9-81ED-4DB2-BD59-A6C34878D82A}">
-                    <a16:rowId xmlns:a16="http://schemas.microsoft.com/office/drawing/2014/main" val="10005"/>
-                  </a:ext>
-                </a:extLst>
-              </a:tr>
-            </a:tbl>
-          </a:graphicData>
-        </a:graphic>
-      </p:graphicFrame>
       <p:sp>
         <p:nvSpPr>
           <p:cNvPr id="92" name="Shape 86"/>
@@ -8452,7 +6597,7 @@
               <a:buNone/>
             </a:pPr>
             <a:r>
-              <a:rPr lang="en-US" sz="2000" dirty="0">
+              <a:rPr lang="en-US" sz="2300" dirty="0">
                 <a:solidFill>
                   <a:srgbClr val="1C1C1C"/>
                 </a:solidFill>
@@ -8460,9 +6605,9 @@
                 <a:ea typeface="Calibri" pitchFamily="34" charset="-122"/>
                 <a:cs typeface="Calibri" pitchFamily="34" charset="-120"/>
               </a:rPr>
-              <a:t>Pocket Passers and Dual Threats show no significant difference in QBR (p = 0.9439), despite radically different playing styles — elite efficiency is achievable through passing volume or rushing dominance equally.</a:t>
+              <a:t>Pocket Passers and Dual Threats show no significant difference in QBR (p = 0.9439), despite radically different playing styles, elite efficiency is achievable through passing volume or rushing dominance equally.</a:t>
             </a:r>
-            <a:endParaRPr lang="en-US" sz="2000" dirty="0"/>
+            <a:endParaRPr lang="en-US" sz="2300" dirty="0"/>
           </a:p>
         </p:txBody>
       </p:sp>
@@ -8474,7 +6619,7 @@
         </p:nvSpPr>
         <p:spPr>
           <a:xfrm>
-            <a:off x="20482560" y="12920472"/>
+            <a:off x="20601432" y="12865608"/>
             <a:ext cx="11978640" cy="658368"/>
           </a:xfrm>
           <a:prstGeom prst="rect">
@@ -8506,7 +6651,7 @@
         </p:nvSpPr>
         <p:spPr>
           <a:xfrm>
-            <a:off x="20482560" y="12920472"/>
+            <a:off x="20601432" y="12865608"/>
             <a:ext cx="128016" cy="658368"/>
           </a:xfrm>
           <a:prstGeom prst="rect">
@@ -8538,7 +6683,7 @@
         </p:nvSpPr>
         <p:spPr>
           <a:xfrm>
-            <a:off x="20711160" y="12920472"/>
+            <a:off x="20830032" y="12865608"/>
             <a:ext cx="11750040" cy="658368"/>
           </a:xfrm>
           <a:prstGeom prst="rect">
@@ -8573,15 +6718,21 @@
         <p:nvGraphicFramePr>
           <p:cNvPr id="98" name="Chart 0"/>
           <p:cNvGraphicFramePr/>
-          <p:nvPr/>
+          <p:nvPr>
+            <p:extLst>
+              <p:ext uri="{D42A27DB-BD31-4B8C-83A1-F6EECF244321}">
+                <p14:modId xmlns:p14="http://schemas.microsoft.com/office/powerpoint/2010/main" val="307877449"/>
+              </p:ext>
+            </p:extLst>
+          </p:nvPr>
         </p:nvGraphicFramePr>
         <p:xfrm>
-          <a:off x="20482560" y="13697712"/>
+          <a:off x="20601432" y="13642848"/>
           <a:ext cx="11978640" cy="3200400"/>
         </p:xfrm>
         <a:graphic>
           <a:graphicData uri="http://schemas.openxmlformats.org/drawingml/2006/chart">
-            <c:chart xmlns:c="http://schemas.openxmlformats.org/drawingml/2006/chart" xmlns:r="http://schemas.openxmlformats.org/officeDocument/2006/relationships" r:id="rId4"/>
+            <c:chart xmlns:c="http://schemas.openxmlformats.org/drawingml/2006/chart" xmlns:r="http://schemas.openxmlformats.org/officeDocument/2006/relationships" r:id="rId3"/>
           </a:graphicData>
         </a:graphic>
       </p:graphicFrame>
@@ -8593,7 +6744,7 @@
         </p:nvSpPr>
         <p:spPr>
           <a:xfrm>
-            <a:off x="20482560" y="17035272"/>
+            <a:off x="20570952" y="20855866"/>
             <a:ext cx="11978640" cy="548640"/>
           </a:xfrm>
           <a:prstGeom prst="rect">
@@ -8639,6 +6790,36 @@
           <p:nvPr/>
         </p:nvPicPr>
         <p:blipFill>
+          <a:blip r:embed="rId4"/>
+          <a:stretch>
+            <a:fillRect/>
+          </a:stretch>
+        </p:blipFill>
+        <p:spPr>
+          <a:xfrm>
+            <a:off x="20466280" y="18114264"/>
+            <a:ext cx="2724912" cy="2724912"/>
+          </a:xfrm>
+          <a:prstGeom prst="rect">
+            <a:avLst/>
+          </a:prstGeom>
+        </p:spPr>
+      </p:pic>
+      <p:pic>
+        <p:nvPicPr>
+          <p:cNvPr id="102" name="Picture 101" descr="A screenshot of a computer screen&#10;&#10;AI-generated content may be incorrect.">
+            <a:extLst>
+              <a:ext uri="{FF2B5EF4-FFF2-40B4-BE49-F238E27FC236}">
+                <a16:creationId xmlns:a16="http://schemas.microsoft.com/office/drawing/2014/main" id="{7521B27D-88BB-230F-9928-D2B2C226930F}"/>
+              </a:ext>
+            </a:extLst>
+          </p:cNvPr>
+          <p:cNvPicPr>
+            <a:picLocks noChangeAspect="1"/>
+          </p:cNvPicPr>
+          <p:nvPr/>
+        </p:nvPicPr>
+        <p:blipFill>
           <a:blip r:embed="rId5"/>
           <a:stretch>
             <a:fillRect/>
@@ -8646,14 +6827,128 @@
         </p:blipFill>
         <p:spPr>
           <a:xfrm>
-            <a:off x="338328" y="18685764"/>
-            <a:ext cx="2724912" cy="2724912"/>
+            <a:off x="20646536" y="5571684"/>
+            <a:ext cx="11650688" cy="5218236"/>
           </a:xfrm>
           <a:prstGeom prst="rect">
             <a:avLst/>
           </a:prstGeom>
         </p:spPr>
       </p:pic>
+      <p:pic>
+        <p:nvPicPr>
+          <p:cNvPr id="104" name="Picture 103" descr="A diagram of a number of clusters&#10;&#10;AI-generated content may be incorrect.">
+            <a:extLst>
+              <a:ext uri="{FF2B5EF4-FFF2-40B4-BE49-F238E27FC236}">
+                <a16:creationId xmlns:a16="http://schemas.microsoft.com/office/drawing/2014/main" id="{30358F56-129A-2CA0-CD70-E943061F04B4}"/>
+              </a:ext>
+            </a:extLst>
+          </p:cNvPr>
+          <p:cNvPicPr>
+            <a:picLocks noChangeAspect="1"/>
+          </p:cNvPicPr>
+          <p:nvPr/>
+        </p:nvPicPr>
+        <p:blipFill>
+          <a:blip r:embed="rId6"/>
+          <a:stretch>
+            <a:fillRect/>
+          </a:stretch>
+        </p:blipFill>
+        <p:spPr>
+          <a:xfrm>
+            <a:off x="9707662" y="3794760"/>
+            <a:ext cx="9662595" cy="6857612"/>
+          </a:xfrm>
+          <a:prstGeom prst="rect">
+            <a:avLst/>
+          </a:prstGeom>
+        </p:spPr>
+      </p:pic>
+      <p:sp>
+        <p:nvSpPr>
+          <p:cNvPr id="107" name="Shape 77">
+            <a:extLst>
+              <a:ext uri="{FF2B5EF4-FFF2-40B4-BE49-F238E27FC236}">
+                <a16:creationId xmlns:a16="http://schemas.microsoft.com/office/drawing/2014/main" id="{4E7C0029-F861-1FB6-B4EB-ADD196C74034}"/>
+              </a:ext>
+            </a:extLst>
+          </p:cNvPr>
+          <p:cNvSpPr/>
+          <p:nvPr/>
+        </p:nvSpPr>
+        <p:spPr>
+          <a:xfrm>
+            <a:off x="20711160" y="17300448"/>
+            <a:ext cx="11978640" cy="658368"/>
+          </a:xfrm>
+          <a:prstGeom prst="rect">
+            <a:avLst/>
+          </a:prstGeom>
+          <a:solidFill>
+            <a:srgbClr val="1A3A5C"/>
+          </a:solidFill>
+          <a:ln w="12700">
+            <a:solidFill>
+              <a:srgbClr val="1A3A5C"/>
+            </a:solidFill>
+            <a:prstDash val="solid"/>
+          </a:ln>
+        </p:spPr>
+        <p:txBody>
+          <a:bodyPr/>
+          <a:lstStyle/>
+          <a:p>
+            <a:r>
+              <a:rPr lang="en-US" sz="2200" b="1" dirty="0">
+                <a:solidFill>
+                  <a:schemeClr val="bg1"/>
+                </a:solidFill>
+                <a:latin typeface="Trebuchet MS" panose="020B0703020202090204" pitchFamily="34" charset="0"/>
+              </a:rPr>
+              <a:t>CODE AND REPRODUCIBILITY</a:t>
+            </a:r>
+          </a:p>
+        </p:txBody>
+      </p:sp>
+      <p:sp>
+        <p:nvSpPr>
+          <p:cNvPr id="108" name="Shape 78">
+            <a:extLst>
+              <a:ext uri="{FF2B5EF4-FFF2-40B4-BE49-F238E27FC236}">
+                <a16:creationId xmlns:a16="http://schemas.microsoft.com/office/drawing/2014/main" id="{8546B00F-F9A4-3194-CF84-E3290EFA5902}"/>
+              </a:ext>
+            </a:extLst>
+          </p:cNvPr>
+          <p:cNvSpPr/>
+          <p:nvPr/>
+        </p:nvSpPr>
+        <p:spPr>
+          <a:xfrm>
+            <a:off x="20564856" y="17314164"/>
+            <a:ext cx="128016" cy="658368"/>
+          </a:xfrm>
+          <a:prstGeom prst="rect">
+            <a:avLst/>
+          </a:prstGeom>
+          <a:solidFill>
+            <a:srgbClr val="F4A620"/>
+          </a:solidFill>
+          <a:ln w="12700">
+            <a:solidFill>
+              <a:srgbClr val="F4A620"/>
+            </a:solidFill>
+            <a:prstDash val="solid"/>
+          </a:ln>
+        </p:spPr>
+        <p:txBody>
+          <a:bodyPr/>
+          <a:lstStyle/>
+          <a:p>
+            <a:endParaRPr lang="en-US"/>
+          </a:p>
+        </p:txBody>
+      </p:sp>
     </p:spTree>
   </p:cSld>
   <p:clrMapOvr>

</xml_diff>